<commit_message>
Uskladi ogledni cas s izvornim obrascem i individualnim i grupnim aktivnostima
</commit_message>
<xml_diff>
--- a/materijali/Prezentacija.pptx
+++ b/materijali/Prezentacija.pptx
@@ -2,42 +2,42 @@
 <file path=ppt/presentation.xml><?xml version="1.0" encoding="utf-8"?>
 <p:presentation xmlns:p="http://schemas.openxmlformats.org/presentationml/2006/main">
   <p:sldMasterIdLst>
-    <p:sldMasterId xmlns:r="http://schemas.openxmlformats.org/officeDocument/2006/relationships" id="2147483648" r:id="R7d91a2ca9cc140a9"/>
+    <p:sldMasterId xmlns:r="http://schemas.openxmlformats.org/officeDocument/2006/relationships" id="2147483648" r:id="R58ed6b5fa9cf4195"/>
   </p:sldMasterIdLst>
   <p:notesMasterIdLst>
-    <p:notesMasterId xmlns:r="http://schemas.openxmlformats.org/officeDocument/2006/relationships" r:id="R55afdd4b782c4062"/>
+    <p:notesMasterId xmlns:r="http://schemas.openxmlformats.org/officeDocument/2006/relationships" r:id="R957f844a8c8b4644"/>
   </p:notesMasterIdLst>
   <p:sldIdLst>
-    <p:sldId xmlns:r="http://schemas.openxmlformats.org/officeDocument/2006/relationships" id="256" r:id="R8bb14bd2bd4940f9"/>
-    <p:sldId xmlns:r="http://schemas.openxmlformats.org/officeDocument/2006/relationships" id="257" r:id="R8f894ac8934142f4"/>
-    <p:sldId xmlns:r="http://schemas.openxmlformats.org/officeDocument/2006/relationships" id="258" r:id="R0149e4ab223e44ef"/>
-    <p:sldId xmlns:r="http://schemas.openxmlformats.org/officeDocument/2006/relationships" id="259" r:id="Rb746082b95b142b5"/>
-    <p:sldId xmlns:r="http://schemas.openxmlformats.org/officeDocument/2006/relationships" id="260" r:id="R38df23ee512544ab"/>
-    <p:sldId xmlns:r="http://schemas.openxmlformats.org/officeDocument/2006/relationships" id="261" r:id="R4a7784108f804a6f"/>
-    <p:sldId xmlns:r="http://schemas.openxmlformats.org/officeDocument/2006/relationships" id="262" r:id="R1d137503f5d04d83"/>
-    <p:sldId xmlns:r="http://schemas.openxmlformats.org/officeDocument/2006/relationships" id="263" r:id="R3f6e408620ea4093"/>
-    <p:sldId xmlns:r="http://schemas.openxmlformats.org/officeDocument/2006/relationships" id="264" r:id="Re0bd7ed8ea8046bd"/>
-    <p:sldId xmlns:r="http://schemas.openxmlformats.org/officeDocument/2006/relationships" id="265" r:id="R0f0f517bb9f4460c"/>
-    <p:sldId xmlns:r="http://schemas.openxmlformats.org/officeDocument/2006/relationships" id="266" r:id="Rc37b78d50a5a4178"/>
-    <p:sldId xmlns:r="http://schemas.openxmlformats.org/officeDocument/2006/relationships" id="267" r:id="R2de99c84ee3c4d01"/>
-    <p:sldId xmlns:r="http://schemas.openxmlformats.org/officeDocument/2006/relationships" id="268" r:id="Ra02a3a644d294df0"/>
-    <p:sldId xmlns:r="http://schemas.openxmlformats.org/officeDocument/2006/relationships" id="269" r:id="R99d5227f13f74013"/>
-    <p:sldId xmlns:r="http://schemas.openxmlformats.org/officeDocument/2006/relationships" id="270" r:id="Rbe1c94e65e934668"/>
-    <p:sldId xmlns:r="http://schemas.openxmlformats.org/officeDocument/2006/relationships" id="271" r:id="R29248edc59af4651"/>
-    <p:sldId xmlns:r="http://schemas.openxmlformats.org/officeDocument/2006/relationships" id="272" r:id="Raecbd825202f4c33"/>
-    <p:sldId xmlns:r="http://schemas.openxmlformats.org/officeDocument/2006/relationships" id="273" r:id="R6085bd588cd7418c"/>
-    <p:sldId xmlns:r="http://schemas.openxmlformats.org/officeDocument/2006/relationships" id="274" r:id="R39a823e948ba457d"/>
-    <p:sldId xmlns:r="http://schemas.openxmlformats.org/officeDocument/2006/relationships" id="275" r:id="Rb41698632e57486f"/>
-    <p:sldId xmlns:r="http://schemas.openxmlformats.org/officeDocument/2006/relationships" id="276" r:id="R4dcc13075c4f443e"/>
-    <p:sldId xmlns:r="http://schemas.openxmlformats.org/officeDocument/2006/relationships" id="277" r:id="Rd26bcfd39200431b"/>
-    <p:sldId xmlns:r="http://schemas.openxmlformats.org/officeDocument/2006/relationships" id="278" r:id="Rd965d800c31d40e2"/>
-    <p:sldId xmlns:r="http://schemas.openxmlformats.org/officeDocument/2006/relationships" id="279" r:id="Re2787d7c26a14617"/>
-    <p:sldId xmlns:r="http://schemas.openxmlformats.org/officeDocument/2006/relationships" id="280" r:id="Ra3651494a42f462c"/>
-    <p:sldId xmlns:r="http://schemas.openxmlformats.org/officeDocument/2006/relationships" id="281" r:id="Rd54b6ab809404819"/>
-    <p:sldId xmlns:r="http://schemas.openxmlformats.org/officeDocument/2006/relationships" id="282" r:id="R5705cf1543414a21"/>
-    <p:sldId xmlns:r="http://schemas.openxmlformats.org/officeDocument/2006/relationships" id="283" r:id="Rb9d2fbf3abed4e73"/>
-    <p:sldId xmlns:r="http://schemas.openxmlformats.org/officeDocument/2006/relationships" id="284" r:id="Ra4d9e88a2f3044a6"/>
-    <p:sldId xmlns:r="http://schemas.openxmlformats.org/officeDocument/2006/relationships" id="285" r:id="Ra1adc37402ff4db1"/>
+    <p:sldId xmlns:r="http://schemas.openxmlformats.org/officeDocument/2006/relationships" id="256" r:id="R792abab4d4314f98"/>
+    <p:sldId xmlns:r="http://schemas.openxmlformats.org/officeDocument/2006/relationships" id="257" r:id="R541e41bc368b4d3a"/>
+    <p:sldId xmlns:r="http://schemas.openxmlformats.org/officeDocument/2006/relationships" id="258" r:id="R191935fc0d524393"/>
+    <p:sldId xmlns:r="http://schemas.openxmlformats.org/officeDocument/2006/relationships" id="259" r:id="Rd417a98a1d534e03"/>
+    <p:sldId xmlns:r="http://schemas.openxmlformats.org/officeDocument/2006/relationships" id="260" r:id="R3b89c40ca15b4bae"/>
+    <p:sldId xmlns:r="http://schemas.openxmlformats.org/officeDocument/2006/relationships" id="261" r:id="R24b0b66bc9ec4bce"/>
+    <p:sldId xmlns:r="http://schemas.openxmlformats.org/officeDocument/2006/relationships" id="262" r:id="Rd977906bb21c40dc"/>
+    <p:sldId xmlns:r="http://schemas.openxmlformats.org/officeDocument/2006/relationships" id="263" r:id="Rbbae7094518044f1"/>
+    <p:sldId xmlns:r="http://schemas.openxmlformats.org/officeDocument/2006/relationships" id="264" r:id="R33fd9bab97394620"/>
+    <p:sldId xmlns:r="http://schemas.openxmlformats.org/officeDocument/2006/relationships" id="265" r:id="Rf1d491cdb6c84c58"/>
+    <p:sldId xmlns:r="http://schemas.openxmlformats.org/officeDocument/2006/relationships" id="266" r:id="Rcf4282f1721c4808"/>
+    <p:sldId xmlns:r="http://schemas.openxmlformats.org/officeDocument/2006/relationships" id="267" r:id="R91438b0516e44673"/>
+    <p:sldId xmlns:r="http://schemas.openxmlformats.org/officeDocument/2006/relationships" id="268" r:id="Reffb8ede04744778"/>
+    <p:sldId xmlns:r="http://schemas.openxmlformats.org/officeDocument/2006/relationships" id="269" r:id="Rf531e55cd9494838"/>
+    <p:sldId xmlns:r="http://schemas.openxmlformats.org/officeDocument/2006/relationships" id="270" r:id="R89133331b7ce41b2"/>
+    <p:sldId xmlns:r="http://schemas.openxmlformats.org/officeDocument/2006/relationships" id="271" r:id="R33ffafe253b64b86"/>
+    <p:sldId xmlns:r="http://schemas.openxmlformats.org/officeDocument/2006/relationships" id="272" r:id="Rb48c6eb854b44099"/>
+    <p:sldId xmlns:r="http://schemas.openxmlformats.org/officeDocument/2006/relationships" id="273" r:id="Rc14107ac7ffd418a"/>
+    <p:sldId xmlns:r="http://schemas.openxmlformats.org/officeDocument/2006/relationships" id="274" r:id="R54f15a774894420a"/>
+    <p:sldId xmlns:r="http://schemas.openxmlformats.org/officeDocument/2006/relationships" id="275" r:id="Reb14bb5f2b954981"/>
+    <p:sldId xmlns:r="http://schemas.openxmlformats.org/officeDocument/2006/relationships" id="276" r:id="R8df566fc1ecf4f99"/>
+    <p:sldId xmlns:r="http://schemas.openxmlformats.org/officeDocument/2006/relationships" id="277" r:id="Rbe138a8e27bd4758"/>
+    <p:sldId xmlns:r="http://schemas.openxmlformats.org/officeDocument/2006/relationships" id="278" r:id="R5d679725c19b4965"/>
+    <p:sldId xmlns:r="http://schemas.openxmlformats.org/officeDocument/2006/relationships" id="279" r:id="Rffbd46536dea46f5"/>
+    <p:sldId xmlns:r="http://schemas.openxmlformats.org/officeDocument/2006/relationships" id="280" r:id="R79612313155b4f8e"/>
+    <p:sldId xmlns:r="http://schemas.openxmlformats.org/officeDocument/2006/relationships" id="281" r:id="R29522e35f04b41c1"/>
+    <p:sldId xmlns:r="http://schemas.openxmlformats.org/officeDocument/2006/relationships" id="282" r:id="R066bc490421a4e73"/>
+    <p:sldId xmlns:r="http://schemas.openxmlformats.org/officeDocument/2006/relationships" id="283" r:id="R825616af7b93428a"/>
+    <p:sldId xmlns:r="http://schemas.openxmlformats.org/officeDocument/2006/relationships" id="284" r:id="Ra74a388b7d8a4da9"/>
+    <p:sldId xmlns:r="http://schemas.openxmlformats.org/officeDocument/2006/relationships" id="285" r:id="R796898a00ae04e10"/>
   </p:sldIdLst>
   <p:sldSz cx="12192000" cy="6858000"/>
   <p:notesSz cx="6858000" cy="9144000"/>
@@ -479,11 +479,6 @@
               <a:t>Izvor: udžbenik vjeronauke za VIII razred, štampane str. 29–32.</a:t>
             </a:r>
           </a:p>
-          <a:p xmlns:a="http://schemas.openxmlformats.org/drawingml/2006/main">
-            <a:r>
-              <a:t>Napomena o abdestu: https://islamskazajednica.ba/index.php/namaz-ezan/3108-o-namazu ; https://islamskazajednica.ba/index.php/abdest-tjelesna-cistoca/4898-pitanja-o-abdestu</a:t>
-            </a:r>
-          </a:p>
         </p:txBody>
       </p:sp>
       <p:sp>
@@ -559,11 +554,6 @@
               <a:t>Izvor: udžbenik vjeronauke za VIII razred, štampane str. 29–32.</a:t>
             </a:r>
           </a:p>
-          <a:p xmlns:a="http://schemas.openxmlformats.org/drawingml/2006/main">
-            <a:r>
-              <a:t>Napomena o abdestu: https://islamskazajednica.ba/index.php/namaz-ezan/3108-o-namazu ; https://islamskazajednica.ba/index.php/abdest-tjelesna-cistoca/4898-pitanja-o-abdestu</a:t>
-            </a:r>
-          </a:p>
         </p:txBody>
       </p:sp>
       <p:sp>
@@ -631,17 +621,12 @@
           <a:lstStyle xmlns:a="http://schemas.openxmlformats.org/drawingml/2006/main"/>
           <a:p xmlns:a="http://schemas.openxmlformats.org/drawingml/2006/main">
             <a:r>
-              <a:t>Udžbenik, str. 30. Stručna ispravka nepreciznosti izvornog primjera; okolnosti sna i posta pojašnjava nastavnik.</a:t>
+              <a:t>Udžbenik, str. 30. Jedan kratak primjer; bez posebnog izdvajanja ovog pojma u ciljevima časa.</a:t>
             </a:r>
           </a:p>
           <a:p xmlns:a="http://schemas.openxmlformats.org/drawingml/2006/main">
             <a:r>
               <a:t>Izvor: udžbenik vjeronauke za VIII razred, štampane str. 29–32.</a:t>
-            </a:r>
-          </a:p>
-          <a:p xmlns:a="http://schemas.openxmlformats.org/drawingml/2006/main">
-            <a:r>
-              <a:t>Napomena o abdestu: https://islamskazajednica.ba/index.php/namaz-ezan/3108-o-namazu ; https://islamskazajednica.ba/index.php/abdest-tjelesna-cistoca/4898-pitanja-o-abdestu</a:t>
             </a:r>
           </a:p>
         </p:txBody>
@@ -719,11 +704,6 @@
               <a:t>Izvor: udžbenik vjeronauke za VIII razred, štampane str. 29–32.</a:t>
             </a:r>
           </a:p>
-          <a:p xmlns:a="http://schemas.openxmlformats.org/drawingml/2006/main">
-            <a:r>
-              <a:t>Napomena o abdestu: https://islamskazajednica.ba/index.php/namaz-ezan/3108-o-namazu ; https://islamskazajednica.ba/index.php/abdest-tjelesna-cistoca/4898-pitanja-o-abdestu</a:t>
-            </a:r>
-          </a:p>
         </p:txBody>
       </p:sp>
       <p:sp>
@@ -799,11 +779,6 @@
               <a:t>Izvor: udžbenik vjeronauke za VIII razred, štampane str. 29–32.</a:t>
             </a:r>
           </a:p>
-          <a:p xmlns:a="http://schemas.openxmlformats.org/drawingml/2006/main">
-            <a:r>
-              <a:t>Napomena o abdestu: https://islamskazajednica.ba/index.php/namaz-ezan/3108-o-namazu ; https://islamskazajednica.ba/index.php/abdest-tjelesna-cistoca/4898-pitanja-o-abdestu</a:t>
-            </a:r>
-          </a:p>
         </p:txBody>
       </p:sp>
       <p:sp>
@@ -879,11 +854,6 @@
               <a:t>Izvor: udžbenik vjeronauke za VIII razred, štampane str. 29–32.</a:t>
             </a:r>
           </a:p>
-          <a:p xmlns:a="http://schemas.openxmlformats.org/drawingml/2006/main">
-            <a:r>
-              <a:t>Napomena o abdestu: https://islamskazajednica.ba/index.php/namaz-ezan/3108-o-namazu ; https://islamskazajednica.ba/index.php/abdest-tjelesna-cistoca/4898-pitanja-o-abdestu</a:t>
-            </a:r>
-          </a:p>
         </p:txBody>
       </p:sp>
       <p:sp>
@@ -959,11 +929,6 @@
               <a:t>Izvor: udžbenik vjeronauke za VIII razred, štampane str. 29–32.</a:t>
             </a:r>
           </a:p>
-          <a:p xmlns:a="http://schemas.openxmlformats.org/drawingml/2006/main">
-            <a:r>
-              <a:t>Napomena o abdestu: https://islamskazajednica.ba/index.php/namaz-ezan/3108-o-namazu ; https://islamskazajednica.ba/index.php/abdest-tjelesna-cistoca/4898-pitanja-o-abdestu</a:t>
-            </a:r>
-          </a:p>
         </p:txBody>
       </p:sp>
       <p:sp>
@@ -1039,11 +1004,6 @@
               <a:t>Izvor: udžbenik vjeronauke za VIII razred, štampane str. 29–32.</a:t>
             </a:r>
           </a:p>
-          <a:p xmlns:a="http://schemas.openxmlformats.org/drawingml/2006/main">
-            <a:r>
-              <a:t>Napomena o abdestu: https://islamskazajednica.ba/index.php/namaz-ezan/3108-o-namazu ; https://islamskazajednica.ba/index.php/abdest-tjelesna-cistoca/4898-pitanja-o-abdestu</a:t>
-            </a:r>
-          </a:p>
         </p:txBody>
       </p:sp>
       <p:sp>
@@ -1119,11 +1079,6 @@
               <a:t>Izvor: udžbenik vjeronauke za VIII razred, štampane str. 29–32.</a:t>
             </a:r>
           </a:p>
-          <a:p xmlns:a="http://schemas.openxmlformats.org/drawingml/2006/main">
-            <a:r>
-              <a:t>Napomena o abdestu: https://islamskazajednica.ba/index.php/namaz-ezan/3108-o-namazu ; https://islamskazajednica.ba/index.php/abdest-tjelesna-cistoca/4898-pitanja-o-abdestu</a:t>
-            </a:r>
-          </a:p>
         </p:txBody>
       </p:sp>
       <p:sp>
@@ -1199,11 +1154,6 @@
               <a:t>Izvor: udžbenik vjeronauke za VIII razred, štampane str. 29–32.</a:t>
             </a:r>
           </a:p>
-          <a:p xmlns:a="http://schemas.openxmlformats.org/drawingml/2006/main">
-            <a:r>
-              <a:t>Napomena o abdestu: https://islamskazajednica.ba/index.php/namaz-ezan/3108-o-namazu ; https://islamskazajednica.ba/index.php/abdest-tjelesna-cistoca/4898-pitanja-o-abdestu</a:t>
-            </a:r>
-          </a:p>
         </p:txBody>
       </p:sp>
       <p:sp>
@@ -1279,11 +1229,6 @@
               <a:t>Izvor: udžbenik vjeronauke za VIII razred, štampane str. 29–32.</a:t>
             </a:r>
           </a:p>
-          <a:p xmlns:a="http://schemas.openxmlformats.org/drawingml/2006/main">
-            <a:r>
-              <a:t>Napomena o abdestu: https://islamskazajednica.ba/index.php/namaz-ezan/3108-o-namazu ; https://islamskazajednica.ba/index.php/abdest-tjelesna-cistoca/4898-pitanja-o-abdestu</a:t>
-            </a:r>
-          </a:p>
         </p:txBody>
       </p:sp>
       <p:sp>
@@ -1359,11 +1304,6 @@
               <a:t>Izvor: udžbenik vjeronauke za VIII razred, štampane str. 29–32.</a:t>
             </a:r>
           </a:p>
-          <a:p xmlns:a="http://schemas.openxmlformats.org/drawingml/2006/main">
-            <a:r>
-              <a:t>Napomena o abdestu: https://islamskazajednica.ba/index.php/namaz-ezan/3108-o-namazu ; https://islamskazajednica.ba/index.php/abdest-tjelesna-cistoca/4898-pitanja-o-abdestu</a:t>
-            </a:r>
-          </a:p>
         </p:txBody>
       </p:sp>
       <p:sp>
@@ -1439,11 +1379,6 @@
               <a:t>Izvor: udžbenik vjeronauke za VIII razred, štampane str. 29–32.</a:t>
             </a:r>
           </a:p>
-          <a:p xmlns:a="http://schemas.openxmlformats.org/drawingml/2006/main">
-            <a:r>
-              <a:t>Napomena o abdestu: https://islamskazajednica.ba/index.php/namaz-ezan/3108-o-namazu ; https://islamskazajednica.ba/index.php/abdest-tjelesna-cistoca/4898-pitanja-o-abdestu</a:t>
-            </a:r>
-          </a:p>
         </p:txBody>
       </p:sp>
       <p:sp>
@@ -1519,11 +1454,6 @@
               <a:t>Izvor: udžbenik vjeronauke za VIII razred, štampane str. 29–32.</a:t>
             </a:r>
           </a:p>
-          <a:p xmlns:a="http://schemas.openxmlformats.org/drawingml/2006/main">
-            <a:r>
-              <a:t>Napomena o abdestu: https://islamskazajednica.ba/index.php/namaz-ezan/3108-o-namazu ; https://islamskazajednica.ba/index.php/abdest-tjelesna-cistoca/4898-pitanja-o-abdestu</a:t>
-            </a:r>
-          </a:p>
         </p:txBody>
       </p:sp>
       <p:sp>
@@ -1599,11 +1529,6 @@
               <a:t>Izvor: udžbenik vjeronauke za VIII razred, štampane str. 29–32.</a:t>
             </a:r>
           </a:p>
-          <a:p xmlns:a="http://schemas.openxmlformats.org/drawingml/2006/main">
-            <a:r>
-              <a:t>Napomena o abdestu: https://islamskazajednica.ba/index.php/namaz-ezan/3108-o-namazu ; https://islamskazajednica.ba/index.php/abdest-tjelesna-cistoca/4898-pitanja-o-abdestu</a:t>
-            </a:r>
-          </a:p>
         </p:txBody>
       </p:sp>
       <p:sp>
@@ -1671,17 +1596,12 @@
           <a:lstStyle xmlns:a="http://schemas.openxmlformats.org/drawingml/2006/main"/>
           <a:p xmlns:a="http://schemas.openxmlformats.org/drawingml/2006/main">
             <a:r>
-              <a:t>Tačan odgovor: A. Mufsid se povezuje s konkretnim ibadetom. Govor kvari namaz; sam govor nije uzrok gubitka abdesta.</a:t>
+              <a:t>Tačan odgovor: A. Farz je stroga dužnost, dok se za mustehab nagrađuje, a njegovo izostavljanje ne kažnjava.</a:t>
             </a:r>
           </a:p>
           <a:p xmlns:a="http://schemas.openxmlformats.org/drawingml/2006/main">
             <a:r>
               <a:t>Izvor: udžbenik vjeronauke za VIII razred, štampane str. 29–32.</a:t>
-            </a:r>
-          </a:p>
-          <a:p xmlns:a="http://schemas.openxmlformats.org/drawingml/2006/main">
-            <a:r>
-              <a:t>Napomena o abdestu: https://islamskazajednica.ba/index.php/namaz-ezan/3108-o-namazu ; https://islamskazajednica.ba/index.php/abdest-tjelesna-cistoca/4898-pitanja-o-abdestu</a:t>
             </a:r>
           </a:p>
         </p:txBody>
@@ -1759,11 +1679,6 @@
               <a:t>Izvor: udžbenik vjeronauke za VIII razred, štampane str. 29–32.</a:t>
             </a:r>
           </a:p>
-          <a:p xmlns:a="http://schemas.openxmlformats.org/drawingml/2006/main">
-            <a:r>
-              <a:t>Napomena o abdestu: https://islamskazajednica.ba/index.php/namaz-ezan/3108-o-namazu ; https://islamskazajednica.ba/index.php/abdest-tjelesna-cistoca/4898-pitanja-o-abdestu</a:t>
-            </a:r>
-          </a:p>
         </p:txBody>
       </p:sp>
       <p:sp>
@@ -1839,11 +1754,6 @@
               <a:t>Izvor: udžbenik vjeronauke za VIII razred, štampane str. 29–32.</a:t>
             </a:r>
           </a:p>
-          <a:p xmlns:a="http://schemas.openxmlformats.org/drawingml/2006/main">
-            <a:r>
-              <a:t>Napomena o abdestu: https://islamskazajednica.ba/index.php/namaz-ezan/3108-o-namazu ; https://islamskazajednica.ba/index.php/abdest-tjelesna-cistoca/4898-pitanja-o-abdestu</a:t>
-            </a:r>
-          </a:p>
         </p:txBody>
       </p:sp>
       <p:sp>
@@ -1919,11 +1829,6 @@
               <a:t>Izvor: udžbenik vjeronauke za VIII razred, štampane str. 29–32.</a:t>
             </a:r>
           </a:p>
-          <a:p xmlns:a="http://schemas.openxmlformats.org/drawingml/2006/main">
-            <a:r>
-              <a:t>Napomena o abdestu: https://islamskazajednica.ba/index.php/namaz-ezan/3108-o-namazu ; https://islamskazajednica.ba/index.php/abdest-tjelesna-cistoca/4898-pitanja-o-abdestu</a:t>
-            </a:r>
-          </a:p>
         </p:txBody>
       </p:sp>
       <p:sp>
@@ -1999,11 +1904,6 @@
               <a:t>Izvor: udžbenik vjeronauke za VIII razred, štampane str. 29–32.</a:t>
             </a:r>
           </a:p>
-          <a:p xmlns:a="http://schemas.openxmlformats.org/drawingml/2006/main">
-            <a:r>
-              <a:t>Napomena o abdestu: https://islamskazajednica.ba/index.php/namaz-ezan/3108-o-namazu ; https://islamskazajednica.ba/index.php/abdest-tjelesna-cistoca/4898-pitanja-o-abdestu</a:t>
-            </a:r>
-          </a:p>
         </p:txBody>
       </p:sp>
       <p:sp>
@@ -2079,11 +1979,6 @@
               <a:t>Izvor: udžbenik vjeronauke za VIII razred, štampane str. 29–32.</a:t>
             </a:r>
           </a:p>
-          <a:p xmlns:a="http://schemas.openxmlformats.org/drawingml/2006/main">
-            <a:r>
-              <a:t>Napomena o abdestu: https://islamskazajednica.ba/index.php/namaz-ezan/3108-o-namazu ; https://islamskazajednica.ba/index.php/abdest-tjelesna-cistoca/4898-pitanja-o-abdestu</a:t>
-            </a:r>
-          </a:p>
         </p:txBody>
       </p:sp>
       <p:sp>
@@ -2159,11 +2054,6 @@
               <a:t>Izvor: udžbenik vjeronauke za VIII razred, štampane str. 29–32.</a:t>
             </a:r>
           </a:p>
-          <a:p xmlns:a="http://schemas.openxmlformats.org/drawingml/2006/main">
-            <a:r>
-              <a:t>Napomena o abdestu: https://islamskazajednica.ba/index.php/namaz-ezan/3108-o-namazu ; https://islamskazajednica.ba/index.php/abdest-tjelesna-cistoca/4898-pitanja-o-abdestu</a:t>
-            </a:r>
-          </a:p>
         </p:txBody>
       </p:sp>
       <p:sp>
@@ -2239,11 +2129,6 @@
               <a:t>Izvor: udžbenik vjeronauke za VIII razred, štampane str. 29–32.</a:t>
             </a:r>
           </a:p>
-          <a:p xmlns:a="http://schemas.openxmlformats.org/drawingml/2006/main">
-            <a:r>
-              <a:t>Napomena o abdestu: https://islamskazajednica.ba/index.php/namaz-ezan/3108-o-namazu ; https://islamskazajednica.ba/index.php/abdest-tjelesna-cistoca/4898-pitanja-o-abdestu</a:t>
-            </a:r>
-          </a:p>
         </p:txBody>
       </p:sp>
       <p:sp>
@@ -2319,11 +2204,6 @@
               <a:t>Izvor: udžbenik vjeronauke za VIII razred, štampane str. 29–32.</a:t>
             </a:r>
           </a:p>
-          <a:p xmlns:a="http://schemas.openxmlformats.org/drawingml/2006/main">
-            <a:r>
-              <a:t>Napomena o abdestu: https://islamskazajednica.ba/index.php/namaz-ezan/3108-o-namazu ; https://islamskazajednica.ba/index.php/abdest-tjelesna-cistoca/4898-pitanja-o-abdestu</a:t>
-            </a:r>
-          </a:p>
         </p:txBody>
       </p:sp>
       <p:sp>
@@ -2399,11 +2279,6 @@
               <a:t>Izvor: udžbenik vjeronauke za VIII razred, štampane str. 29–32.</a:t>
             </a:r>
           </a:p>
-          <a:p xmlns:a="http://schemas.openxmlformats.org/drawingml/2006/main">
-            <a:r>
-              <a:t>Napomena o abdestu: https://islamskazajednica.ba/index.php/namaz-ezan/3108-o-namazu ; https://islamskazajednica.ba/index.php/abdest-tjelesna-cistoca/4898-pitanja-o-abdestu</a:t>
-            </a:r>
-          </a:p>
         </p:txBody>
       </p:sp>
       <p:sp>
@@ -2479,11 +2354,6 @@
               <a:t>Izvor: udžbenik vjeronauke za VIII razred, štampane str. 29–32.</a:t>
             </a:r>
           </a:p>
-          <a:p xmlns:a="http://schemas.openxmlformats.org/drawingml/2006/main">
-            <a:r>
-              <a:t>Napomena o abdestu: https://islamskazajednica.ba/index.php/namaz-ezan/3108-o-namazu ; https://islamskazajednica.ba/index.php/abdest-tjelesna-cistoca/4898-pitanja-o-abdestu</a:t>
-            </a:r>
-          </a:p>
         </p:txBody>
       </p:sp>
       <p:sp>
@@ -2559,11 +2429,6 @@
               <a:t>Izvor: udžbenik vjeronauke za VIII razred, štampane str. 29–32.</a:t>
             </a:r>
           </a:p>
-          <a:p xmlns:a="http://schemas.openxmlformats.org/drawingml/2006/main">
-            <a:r>
-              <a:t>Napomena o abdestu: https://islamskazajednica.ba/index.php/namaz-ezan/3108-o-namazu ; https://islamskazajednica.ba/index.php/abdest-tjelesna-cistoca/4898-pitanja-o-abdestu</a:t>
-            </a:r>
-          </a:p>
         </p:txBody>
       </p:sp>
       <p:sp>
@@ -2639,11 +2504,6 @@
               <a:t>Izvor: udžbenik vjeronauke za VIII razred, štampane str. 29–32.</a:t>
             </a:r>
           </a:p>
-          <a:p xmlns:a="http://schemas.openxmlformats.org/drawingml/2006/main">
-            <a:r>
-              <a:t>Napomena o abdestu: https://islamskazajednica.ba/index.php/namaz-ezan/3108-o-namazu ; https://islamskazajednica.ba/index.php/abdest-tjelesna-cistoca/4898-pitanja-o-abdestu</a:t>
-            </a:r>
-          </a:p>
         </p:txBody>
       </p:sp>
       <p:sp>
@@ -2719,11 +2579,6 @@
               <a:t>Izvor: udžbenik vjeronauke za VIII razred, štampane str. 29–32.</a:t>
             </a:r>
           </a:p>
-          <a:p xmlns:a="http://schemas.openxmlformats.org/drawingml/2006/main">
-            <a:r>
-              <a:t>Napomena o abdestu: https://islamskazajednica.ba/index.php/namaz-ezan/3108-o-namazu ; https://islamskazajednica.ba/index.php/abdest-tjelesna-cistoca/4898-pitanja-o-abdestu</a:t>
-            </a:r>
-          </a:p>
         </p:txBody>
       </p:sp>
       <p:sp>
@@ -2799,11 +2654,6 @@
               <a:t>Izvor: udžbenik vjeronauke za VIII razred, štampane str. 29–32.</a:t>
             </a:r>
           </a:p>
-          <a:p xmlns:a="http://schemas.openxmlformats.org/drawingml/2006/main">
-            <a:r>
-              <a:t>Napomena o abdestu: https://islamskazajednica.ba/index.php/namaz-ezan/3108-o-namazu ; https://islamskazajednica.ba/index.php/abdest-tjelesna-cistoca/4898-pitanja-o-abdestu</a:t>
-            </a:r>
-          </a:p>
         </p:txBody>
       </p:sp>
       <p:sp>
@@ -2848,7 +2698,7 @@
           <p:cNvPr id="3" name="Title">
             <a:extLst xmlns:a="http://schemas.openxmlformats.org/drawingml/2006/main">
               <a:ext uri="{FF2B5EF4-FFF2-40B4-BE49-F238E27FC236}">
-                <a16:creationId xmlns:a16="http://schemas.microsoft.com/office/drawing/2014/main" id="{921ED9E0-5A1D-453A-8A90-64384D0388CF}"/>
+                <a16:creationId xmlns:a16="http://schemas.microsoft.com/office/drawing/2014/main" id="{235B8474-18DA-429D-A528-FD882825F87A}"/>
               </a:ext>
             </a:extLst>
           </p:cNvPr>
@@ -3077,7 +2927,7 @@
           <p:cNvPr id="2" name="Subtitle">
             <a:extLst xmlns:a="http://schemas.openxmlformats.org/drawingml/2006/main">
               <a:ext uri="{FF2B5EF4-FFF2-40B4-BE49-F238E27FC236}">
-                <a16:creationId xmlns:a16="http://schemas.microsoft.com/office/drawing/2014/main" id="{DCD0C16B-05E8-44C1-8493-B9506CB75FAB}"/>
+                <a16:creationId xmlns:a16="http://schemas.microsoft.com/office/drawing/2014/main" id="{3BA3B263-0B7F-4302-936F-49306067F1B6}"/>
               </a:ext>
             </a:extLst>
           </p:cNvPr>
@@ -3323,7 +3173,7 @@
           <p:cNvPr id="2" name="Section title">
             <a:extLst xmlns:a="http://schemas.openxmlformats.org/drawingml/2006/main">
               <a:ext uri="{FF2B5EF4-FFF2-40B4-BE49-F238E27FC236}">
-                <a16:creationId xmlns:a16="http://schemas.microsoft.com/office/drawing/2014/main" id="{874FB3F0-2A61-4498-A7C7-32298E68E378}"/>
+                <a16:creationId xmlns:a16="http://schemas.microsoft.com/office/drawing/2014/main" id="{9CC178DD-8660-44F0-B44D-BFDF873D976A}"/>
               </a:ext>
             </a:extLst>
           </p:cNvPr>
@@ -3569,7 +3419,7 @@
           <p:cNvPr id="3" name="Title">
             <a:extLst xmlns:a="http://schemas.openxmlformats.org/drawingml/2006/main">
               <a:ext uri="{FF2B5EF4-FFF2-40B4-BE49-F238E27FC236}">
-                <a16:creationId xmlns:a16="http://schemas.microsoft.com/office/drawing/2014/main" id="{4EB6BD1F-0CA4-4828-9DBA-BD888DEB28EE}"/>
+                <a16:creationId xmlns:a16="http://schemas.microsoft.com/office/drawing/2014/main" id="{31E1A124-AEDC-4B44-B205-C387EAA062D8}"/>
               </a:ext>
             </a:extLst>
           </p:cNvPr>
@@ -3798,7 +3648,7 @@
           <p:cNvPr id="2" name="Body">
             <a:extLst xmlns:a="http://schemas.openxmlformats.org/drawingml/2006/main">
               <a:ext uri="{FF2B5EF4-FFF2-40B4-BE49-F238E27FC236}">
-                <a16:creationId xmlns:a16="http://schemas.microsoft.com/office/drawing/2014/main" id="{B198E9E3-2603-4792-AFDE-FD59FDB0C418}"/>
+                <a16:creationId xmlns:a16="http://schemas.microsoft.com/office/drawing/2014/main" id="{875A73BB-7A3E-48D1-8DDD-D0C8D7A93D13}"/>
               </a:ext>
             </a:extLst>
           </p:cNvPr>
@@ -4044,7 +3894,7 @@
           <p:cNvPr id="4" name="Title">
             <a:extLst xmlns:a="http://schemas.openxmlformats.org/drawingml/2006/main">
               <a:ext uri="{FF2B5EF4-FFF2-40B4-BE49-F238E27FC236}">
-                <a16:creationId xmlns:a16="http://schemas.microsoft.com/office/drawing/2014/main" id="{943B9920-A4AD-4889-8D19-B6A1FFEF4198}"/>
+                <a16:creationId xmlns:a16="http://schemas.microsoft.com/office/drawing/2014/main" id="{D9FE831A-29E0-440F-A20F-65815FBB7451}"/>
               </a:ext>
             </a:extLst>
           </p:cNvPr>
@@ -4273,7 +4123,7 @@
           <p:cNvPr id="2" name="Left column">
             <a:extLst xmlns:a="http://schemas.openxmlformats.org/drawingml/2006/main">
               <a:ext uri="{FF2B5EF4-FFF2-40B4-BE49-F238E27FC236}">
-                <a16:creationId xmlns:a16="http://schemas.microsoft.com/office/drawing/2014/main" id="{FEF75A62-A5BB-4DA6-84A5-F4C003ED03FA}"/>
+                <a16:creationId xmlns:a16="http://schemas.microsoft.com/office/drawing/2014/main" id="{0D52631C-CEAB-416B-8125-C796B47B71D7}"/>
               </a:ext>
             </a:extLst>
           </p:cNvPr>
@@ -4502,7 +4352,7 @@
           <p:cNvPr id="3" name="Right column">
             <a:extLst xmlns:a="http://schemas.openxmlformats.org/drawingml/2006/main">
               <a:ext uri="{FF2B5EF4-FFF2-40B4-BE49-F238E27FC236}">
-                <a16:creationId xmlns:a16="http://schemas.microsoft.com/office/drawing/2014/main" id="{CB3746DF-711F-40C0-8824-1CA247E28C12}"/>
+                <a16:creationId xmlns:a16="http://schemas.microsoft.com/office/drawing/2014/main" id="{45889DF1-D26C-4911-B9FA-57B29A62F210}"/>
               </a:ext>
             </a:extLst>
           </p:cNvPr>
@@ -4748,7 +4598,7 @@
           <p:cNvPr id="3" name="Title">
             <a:extLst xmlns:a="http://schemas.openxmlformats.org/drawingml/2006/main">
               <a:ext uri="{FF2B5EF4-FFF2-40B4-BE49-F238E27FC236}">
-                <a16:creationId xmlns:a16="http://schemas.microsoft.com/office/drawing/2014/main" id="{BEDAEF52-4B71-43A4-9DC1-5D2F8002267F}"/>
+                <a16:creationId xmlns:a16="http://schemas.microsoft.com/office/drawing/2014/main" id="{97C32EBB-F872-49A4-9CAE-079C59334A97}"/>
               </a:ext>
             </a:extLst>
           </p:cNvPr>
@@ -4977,7 +4827,7 @@
           <p:cNvPr id="2" name="Left column">
             <a:extLst xmlns:a="http://schemas.openxmlformats.org/drawingml/2006/main">
               <a:ext uri="{FF2B5EF4-FFF2-40B4-BE49-F238E27FC236}">
-                <a16:creationId xmlns:a16="http://schemas.microsoft.com/office/drawing/2014/main" id="{CE44A504-A80A-4ACC-9131-64B8946065B5}"/>
+                <a16:creationId xmlns:a16="http://schemas.microsoft.com/office/drawing/2014/main" id="{928EBE46-DF59-4638-8321-210D624BEC7C}"/>
               </a:ext>
             </a:extLst>
           </p:cNvPr>
@@ -5244,12 +5094,12 @@
   </p:cSld>
   <p:clrMap bg1="lt1" tx1="dk1" bg2="lt2" tx2="dk2" accent1="accent1" accent2="accent2" accent3="accent3" accent4="accent4" accent5="accent5" accent6="accent6" hlink="hlink" folHlink="folHlink"/>
   <p:sldLayoutIdLst>
-    <p:sldLayoutId xmlns:r="http://schemas.openxmlformats.org/officeDocument/2006/relationships" id="2147483649" r:id="R47bdf1220fc940bc"/>
-    <p:sldLayoutId xmlns:r="http://schemas.openxmlformats.org/officeDocument/2006/relationships" id="2147483650" r:id="R04790fc1759549c0"/>
-    <p:sldLayoutId xmlns:r="http://schemas.openxmlformats.org/officeDocument/2006/relationships" id="2147483651" r:id="Rbcf36e0d6b244f0a"/>
-    <p:sldLayoutId xmlns:r="http://schemas.openxmlformats.org/officeDocument/2006/relationships" id="2147483652" r:id="R3fb1cf10bd9d4a55"/>
-    <p:sldLayoutId xmlns:r="http://schemas.openxmlformats.org/officeDocument/2006/relationships" id="2147483653" r:id="R7e706a7404a24e6f"/>
-    <p:sldLayoutId xmlns:r="http://schemas.openxmlformats.org/officeDocument/2006/relationships" id="2147483654" r:id="Rb0cdc3b40a384d08"/>
+    <p:sldLayoutId xmlns:r="http://schemas.openxmlformats.org/officeDocument/2006/relationships" id="2147483649" r:id="R9fcda184e7c7424b"/>
+    <p:sldLayoutId xmlns:r="http://schemas.openxmlformats.org/officeDocument/2006/relationships" id="2147483650" r:id="R15e91732a3cf4a4e"/>
+    <p:sldLayoutId xmlns:r="http://schemas.openxmlformats.org/officeDocument/2006/relationships" id="2147483651" r:id="R745c3f50b4ef4409"/>
+    <p:sldLayoutId xmlns:r="http://schemas.openxmlformats.org/officeDocument/2006/relationships" id="2147483652" r:id="Rd36561578faa4138"/>
+    <p:sldLayoutId xmlns:r="http://schemas.openxmlformats.org/officeDocument/2006/relationships" id="2147483653" r:id="R884de0b3292d4c0e"/>
+    <p:sldLayoutId xmlns:r="http://schemas.openxmlformats.org/officeDocument/2006/relationships" id="2147483654" r:id="R3e2217bdef90425c"/>
   </p:sldLayoutIdLst>
   <p:txStyles>
     <p:titleStyle>
@@ -5800,7 +5650,7 @@
           <p:cNvPr id="4" name="title">
             <a:extLst xmlns:a="http://schemas.openxmlformats.org/drawingml/2006/main">
               <a:ext uri="{FF2B5EF4-FFF2-40B4-BE49-F238E27FC236}">
-                <a16:creationId xmlns:a16="http://schemas.microsoft.com/office/drawing/2014/main" id="{8ED3D840-5833-4DF2-8AD5-1E66AE9579EC}"/>
+                <a16:creationId xmlns:a16="http://schemas.microsoft.com/office/drawing/2014/main" id="{772BB1B8-AABA-491E-A0E0-13947EEBF27D}"/>
               </a:ext>
             </a:extLst>
           </p:cNvPr>
@@ -5956,7 +5806,7 @@
           <p:cNvPr id="2" name="body">
             <a:extLst xmlns:a="http://schemas.openxmlformats.org/drawingml/2006/main">
               <a:ext uri="{FF2B5EF4-FFF2-40B4-BE49-F238E27FC236}">
-                <a16:creationId xmlns:a16="http://schemas.microsoft.com/office/drawing/2014/main" id="{562886AD-D726-475C-91FA-D131877878E0}"/>
+                <a16:creationId xmlns:a16="http://schemas.microsoft.com/office/drawing/2014/main" id="{7014BCB4-0B7B-46B3-BED9-5C6DAE0BE3C1}"/>
               </a:ext>
             </a:extLst>
           </p:cNvPr>
@@ -6135,7 +5985,7 @@
           <p:cNvPr id="3" name="page">
             <a:extLst xmlns:a="http://schemas.openxmlformats.org/drawingml/2006/main">
               <a:ext uri="{FF2B5EF4-FFF2-40B4-BE49-F238E27FC236}">
-                <a16:creationId xmlns:a16="http://schemas.microsoft.com/office/drawing/2014/main" id="{204C5A85-A9D1-4211-8983-E6710AFF9BD1}"/>
+                <a16:creationId xmlns:a16="http://schemas.microsoft.com/office/drawing/2014/main" id="{064089ED-9FA2-4745-9396-D5ED21F717F7}"/>
               </a:ext>
             </a:extLst>
           </p:cNvPr>
@@ -6289,7 +6139,7 @@
     </p:spTree>
     <p:extLst>
       <p:ext uri="{BB962C8B-B14F-4D97-AF65-F5344CB8AC3E}">
-        <p14:creationId xmlns:p14="http://schemas.microsoft.com/office/powerpoint/2010/main" val="106362171"/>
+        <p14:creationId xmlns:p14="http://schemas.microsoft.com/office/powerpoint/2010/main" val="1062135932"/>
       </p:ext>
     </p:extLst>
   </p:cSld>
@@ -6320,7 +6170,7 @@
           <p:cNvPr id="4" name="title">
             <a:extLst xmlns:a="http://schemas.openxmlformats.org/drawingml/2006/main">
               <a:ext uri="{FF2B5EF4-FFF2-40B4-BE49-F238E27FC236}">
-                <a16:creationId xmlns:a16="http://schemas.microsoft.com/office/drawing/2014/main" id="{22566E35-0031-4EDD-AE3A-F3CCE7B69147}"/>
+                <a16:creationId xmlns:a16="http://schemas.microsoft.com/office/drawing/2014/main" id="{3B49A6A1-B753-41C6-814D-8C40A78763C8}"/>
               </a:ext>
             </a:extLst>
           </p:cNvPr>
@@ -6476,7 +6326,7 @@
           <p:cNvPr id="2" name="body">
             <a:extLst xmlns:a="http://schemas.openxmlformats.org/drawingml/2006/main">
               <a:ext uri="{FF2B5EF4-FFF2-40B4-BE49-F238E27FC236}">
-                <a16:creationId xmlns:a16="http://schemas.microsoft.com/office/drawing/2014/main" id="{27D3C415-4E13-4654-85EC-C6B43A039C6A}"/>
+                <a16:creationId xmlns:a16="http://schemas.microsoft.com/office/drawing/2014/main" id="{5284EF14-6590-4289-9C76-E53F96D555FC}"/>
               </a:ext>
             </a:extLst>
           </p:cNvPr>
@@ -6660,7 +6510,7 @@
           <p:cNvPr id="3" name="page">
             <a:extLst xmlns:a="http://schemas.openxmlformats.org/drawingml/2006/main">
               <a:ext uri="{FF2B5EF4-FFF2-40B4-BE49-F238E27FC236}">
-                <a16:creationId xmlns:a16="http://schemas.microsoft.com/office/drawing/2014/main" id="{C35921C1-9C2E-495E-A3D6-A20A128BCE8E}"/>
+                <a16:creationId xmlns:a16="http://schemas.microsoft.com/office/drawing/2014/main" id="{EAFD5B01-EF22-4D24-8888-76CEB3645F46}"/>
               </a:ext>
             </a:extLst>
           </p:cNvPr>
@@ -6814,7 +6664,7 @@
     </p:spTree>
     <p:extLst>
       <p:ext uri="{BB962C8B-B14F-4D97-AF65-F5344CB8AC3E}">
-        <p14:creationId xmlns:p14="http://schemas.microsoft.com/office/powerpoint/2010/main" val="1046031589"/>
+        <p14:creationId xmlns:p14="http://schemas.microsoft.com/office/powerpoint/2010/main" val="836996122"/>
       </p:ext>
     </p:extLst>
   </p:cSld>
@@ -6845,7 +6695,7 @@
           <p:cNvPr id="4" name="title">
             <a:extLst xmlns:a="http://schemas.openxmlformats.org/drawingml/2006/main">
               <a:ext uri="{FF2B5EF4-FFF2-40B4-BE49-F238E27FC236}">
-                <a16:creationId xmlns:a16="http://schemas.microsoft.com/office/drawing/2014/main" id="{3E684F3A-FB83-49A9-BAC1-3BDDDBC993FA}"/>
+                <a16:creationId xmlns:a16="http://schemas.microsoft.com/office/drawing/2014/main" id="{EBF2D901-FAC8-48BC-A63F-68FF2D932F0F}"/>
               </a:ext>
             </a:extLst>
           </p:cNvPr>
@@ -7001,7 +6851,7 @@
           <p:cNvPr id="2" name="body">
             <a:extLst xmlns:a="http://schemas.openxmlformats.org/drawingml/2006/main">
               <a:ext uri="{FF2B5EF4-FFF2-40B4-BE49-F238E27FC236}">
-                <a16:creationId xmlns:a16="http://schemas.microsoft.com/office/drawing/2014/main" id="{8A71F822-02E8-4CFE-8487-11E1B052337A}"/>
+                <a16:creationId xmlns:a16="http://schemas.microsoft.com/office/drawing/2014/main" id="{26B468EC-C554-481C-A224-C94D36FDF925}"/>
               </a:ext>
             </a:extLst>
           </p:cNvPr>
@@ -7175,35 +7025,7 @@
                 <a:ea typeface="Arial"/>
                 <a:cs typeface="Arial"/>
               </a:rPr>
-              <a:t>Primjeri iz lekcije: govor u namazu, san, uzimanje hrane ili pića u vrijeme posta.</a:t>
-            </a:r>
-          </a:p>
-          <a:p xmlns:a="http://schemas.openxmlformats.org/drawingml/2006/main">
-            <a:r>
-              <a:t/>
-            </a:r>
-          </a:p>
-          <a:p xmlns:a="http://schemas.openxmlformats.org/drawingml/2006/main">
-            <a:pPr>
-              <a:defRPr sz="2400" b="0">
-                <a:solidFill>
-                  <a:srgbClr val="203C35"/>
-                </a:solidFill>
-                <a:latin typeface="Arial"/>
-                <a:ea typeface="Arial"/>
-                <a:cs typeface="Arial"/>
-              </a:defRPr>
-            </a:pPr>
-            <a:r>
-              <a:rPr sz="2400" b="0">
-                <a:solidFill>
-                  <a:srgbClr val="203C35"/>
-                </a:solidFill>
-                <a:latin typeface="Arial"/>
-                <a:ea typeface="Arial"/>
-                <a:cs typeface="Arial"/>
-              </a:rPr>
-              <a:t>Obični govor kvari namaz, ali sam po sebi ne kvari abdest.</a:t>
+              <a:t>Primjer: namjerno uzimanje hrane ili pića tokom posta, bez opravdanog razloga, kvari post.</a:t>
             </a:r>
           </a:p>
         </p:txBody>
@@ -7213,7 +7035,7 @@
           <p:cNvPr id="3" name="page">
             <a:extLst xmlns:a="http://schemas.openxmlformats.org/drawingml/2006/main">
               <a:ext uri="{FF2B5EF4-FFF2-40B4-BE49-F238E27FC236}">
-                <a16:creationId xmlns:a16="http://schemas.microsoft.com/office/drawing/2014/main" id="{62FFC733-C741-4BF2-A509-A171ABFD1438}"/>
+                <a16:creationId xmlns:a16="http://schemas.microsoft.com/office/drawing/2014/main" id="{D4486561-0DA1-40EF-9997-A23348265733}"/>
               </a:ext>
             </a:extLst>
           </p:cNvPr>
@@ -7367,7 +7189,7 @@
     </p:spTree>
     <p:extLst>
       <p:ext uri="{BB962C8B-B14F-4D97-AF65-F5344CB8AC3E}">
-        <p14:creationId xmlns:p14="http://schemas.microsoft.com/office/powerpoint/2010/main" val="525515691"/>
+        <p14:creationId xmlns:p14="http://schemas.microsoft.com/office/powerpoint/2010/main" val="1203992055"/>
       </p:ext>
     </p:extLst>
   </p:cSld>
@@ -7398,7 +7220,7 @@
           <p:cNvPr id="4" name="title">
             <a:extLst xmlns:a="http://schemas.openxmlformats.org/drawingml/2006/main">
               <a:ext uri="{FF2B5EF4-FFF2-40B4-BE49-F238E27FC236}">
-                <a16:creationId xmlns:a16="http://schemas.microsoft.com/office/drawing/2014/main" id="{5C0400BD-36D2-4F57-8E4F-AFDBD24D8274}"/>
+                <a16:creationId xmlns:a16="http://schemas.microsoft.com/office/drawing/2014/main" id="{0A06A63C-B429-4584-A8F5-D817192F9B87}"/>
               </a:ext>
             </a:extLst>
           </p:cNvPr>
@@ -7554,7 +7376,7 @@
           <p:cNvPr id="2" name="body">
             <a:extLst xmlns:a="http://schemas.openxmlformats.org/drawingml/2006/main">
               <a:ext uri="{FF2B5EF4-FFF2-40B4-BE49-F238E27FC236}">
-                <a16:creationId xmlns:a16="http://schemas.microsoft.com/office/drawing/2014/main" id="{CB468604-C05E-4386-BA0D-55A1FD206940}"/>
+                <a16:creationId xmlns:a16="http://schemas.microsoft.com/office/drawing/2014/main" id="{5BF23D77-B30E-45E1-B466-AD8DCC3E462D}"/>
               </a:ext>
             </a:extLst>
           </p:cNvPr>
@@ -7784,7 +7606,7 @@
           <p:cNvPr id="3" name="page">
             <a:extLst xmlns:a="http://schemas.openxmlformats.org/drawingml/2006/main">
               <a:ext uri="{FF2B5EF4-FFF2-40B4-BE49-F238E27FC236}">
-                <a16:creationId xmlns:a16="http://schemas.microsoft.com/office/drawing/2014/main" id="{454448AB-15E6-4230-823C-18E8775D957A}"/>
+                <a16:creationId xmlns:a16="http://schemas.microsoft.com/office/drawing/2014/main" id="{AF2194C6-368B-4A51-A094-780A5FAA5B8D}"/>
               </a:ext>
             </a:extLst>
           </p:cNvPr>
@@ -7938,7 +7760,7 @@
     </p:spTree>
     <p:extLst>
       <p:ext uri="{BB962C8B-B14F-4D97-AF65-F5344CB8AC3E}">
-        <p14:creationId xmlns:p14="http://schemas.microsoft.com/office/powerpoint/2010/main" val="1398825700"/>
+        <p14:creationId xmlns:p14="http://schemas.microsoft.com/office/powerpoint/2010/main" val="123043298"/>
       </p:ext>
     </p:extLst>
   </p:cSld>
@@ -7969,7 +7791,7 @@
           <p:cNvPr id="4" name="title">
             <a:extLst xmlns:a="http://schemas.openxmlformats.org/drawingml/2006/main">
               <a:ext uri="{FF2B5EF4-FFF2-40B4-BE49-F238E27FC236}">
-                <a16:creationId xmlns:a16="http://schemas.microsoft.com/office/drawing/2014/main" id="{476BB8C8-AEF5-4EA2-ACCE-7D23BF485F1A}"/>
+                <a16:creationId xmlns:a16="http://schemas.microsoft.com/office/drawing/2014/main" id="{38F95805-E2D0-417D-AE42-FCF395C02CC5}"/>
               </a:ext>
             </a:extLst>
           </p:cNvPr>
@@ -8125,7 +7947,7 @@
           <p:cNvPr id="2" name="body">
             <a:extLst xmlns:a="http://schemas.openxmlformats.org/drawingml/2006/main">
               <a:ext uri="{FF2B5EF4-FFF2-40B4-BE49-F238E27FC236}">
-                <a16:creationId xmlns:a16="http://schemas.microsoft.com/office/drawing/2014/main" id="{17606ECB-8F5F-4088-8CD4-B24FEB762664}"/>
+                <a16:creationId xmlns:a16="http://schemas.microsoft.com/office/drawing/2014/main" id="{469E22CD-515F-400C-A6EF-2EB4CDE2FB59}"/>
               </a:ext>
             </a:extLst>
           </p:cNvPr>
@@ -8281,7 +8103,7 @@
           <p:cNvPr id="3" name="page">
             <a:extLst xmlns:a="http://schemas.openxmlformats.org/drawingml/2006/main">
               <a:ext uri="{FF2B5EF4-FFF2-40B4-BE49-F238E27FC236}">
-                <a16:creationId xmlns:a16="http://schemas.microsoft.com/office/drawing/2014/main" id="{B08EA598-5DEF-48F0-AAE3-AB3ABAA91230}"/>
+                <a16:creationId xmlns:a16="http://schemas.microsoft.com/office/drawing/2014/main" id="{BC3BDB0B-C6E9-4350-BB9F-9A4E2C672A0B}"/>
               </a:ext>
             </a:extLst>
           </p:cNvPr>
@@ -8435,7 +8257,7 @@
     </p:spTree>
     <p:extLst>
       <p:ext uri="{BB962C8B-B14F-4D97-AF65-F5344CB8AC3E}">
-        <p14:creationId xmlns:p14="http://schemas.microsoft.com/office/powerpoint/2010/main" val="552931033"/>
+        <p14:creationId xmlns:p14="http://schemas.microsoft.com/office/powerpoint/2010/main" val="766462682"/>
       </p:ext>
     </p:extLst>
   </p:cSld>
@@ -8466,7 +8288,7 @@
           <p:cNvPr id="4" name="title">
             <a:extLst xmlns:a="http://schemas.openxmlformats.org/drawingml/2006/main">
               <a:ext uri="{FF2B5EF4-FFF2-40B4-BE49-F238E27FC236}">
-                <a16:creationId xmlns:a16="http://schemas.microsoft.com/office/drawing/2014/main" id="{D271EE0D-4C79-4329-9D10-5CD3FFBD59B5}"/>
+                <a16:creationId xmlns:a16="http://schemas.microsoft.com/office/drawing/2014/main" id="{C2F6D309-01B8-4096-B68E-C03B4A2B35C1}"/>
               </a:ext>
             </a:extLst>
           </p:cNvPr>
@@ -8622,7 +8444,7 @@
           <p:cNvPr id="2" name="body">
             <a:extLst xmlns:a="http://schemas.openxmlformats.org/drawingml/2006/main">
               <a:ext uri="{FF2B5EF4-FFF2-40B4-BE49-F238E27FC236}">
-                <a16:creationId xmlns:a16="http://schemas.microsoft.com/office/drawing/2014/main" id="{6724441A-84E4-46BF-BDAE-0DCF80A7DAD8}"/>
+                <a16:creationId xmlns:a16="http://schemas.microsoft.com/office/drawing/2014/main" id="{92664A1A-3539-4E74-9AD9-CCC95A4BC439}"/>
               </a:ext>
             </a:extLst>
           </p:cNvPr>
@@ -8778,7 +8600,7 @@
           <p:cNvPr id="3" name="page">
             <a:extLst xmlns:a="http://schemas.openxmlformats.org/drawingml/2006/main">
               <a:ext uri="{FF2B5EF4-FFF2-40B4-BE49-F238E27FC236}">
-                <a16:creationId xmlns:a16="http://schemas.microsoft.com/office/drawing/2014/main" id="{81B5B3D6-8F2A-4746-B2DC-E0F62B8EB716}"/>
+                <a16:creationId xmlns:a16="http://schemas.microsoft.com/office/drawing/2014/main" id="{65155B09-FBCF-4334-A9FF-B497A71F40A8}"/>
               </a:ext>
             </a:extLst>
           </p:cNvPr>
@@ -8932,7 +8754,7 @@
     </p:spTree>
     <p:extLst>
       <p:ext uri="{BB962C8B-B14F-4D97-AF65-F5344CB8AC3E}">
-        <p14:creationId xmlns:p14="http://schemas.microsoft.com/office/powerpoint/2010/main" val="1075142502"/>
+        <p14:creationId xmlns:p14="http://schemas.microsoft.com/office/powerpoint/2010/main" val="968361254"/>
       </p:ext>
     </p:extLst>
   </p:cSld>
@@ -8963,7 +8785,7 @@
           <p:cNvPr id="4" name="title">
             <a:extLst xmlns:a="http://schemas.openxmlformats.org/drawingml/2006/main">
               <a:ext uri="{FF2B5EF4-FFF2-40B4-BE49-F238E27FC236}">
-                <a16:creationId xmlns:a16="http://schemas.microsoft.com/office/drawing/2014/main" id="{0688CEA6-B383-4AD5-A819-117719215525}"/>
+                <a16:creationId xmlns:a16="http://schemas.microsoft.com/office/drawing/2014/main" id="{69949D64-5507-49DF-A24A-ED1BB7D190D2}"/>
               </a:ext>
             </a:extLst>
           </p:cNvPr>
@@ -9119,7 +8941,7 @@
           <p:cNvPr id="2" name="body">
             <a:extLst xmlns:a="http://schemas.openxmlformats.org/drawingml/2006/main">
               <a:ext uri="{FF2B5EF4-FFF2-40B4-BE49-F238E27FC236}">
-                <a16:creationId xmlns:a16="http://schemas.microsoft.com/office/drawing/2014/main" id="{53D7030C-3230-49F3-A5B6-4113DA04D1EC}"/>
+                <a16:creationId xmlns:a16="http://schemas.microsoft.com/office/drawing/2014/main" id="{FF7BB53B-345C-4A6C-9715-9A386C06DA6E}"/>
               </a:ext>
             </a:extLst>
           </p:cNvPr>
@@ -9349,7 +9171,7 @@
           <p:cNvPr id="3" name="page">
             <a:extLst xmlns:a="http://schemas.openxmlformats.org/drawingml/2006/main">
               <a:ext uri="{FF2B5EF4-FFF2-40B4-BE49-F238E27FC236}">
-                <a16:creationId xmlns:a16="http://schemas.microsoft.com/office/drawing/2014/main" id="{FD010088-DD7F-4355-9B92-168CA40F7009}"/>
+                <a16:creationId xmlns:a16="http://schemas.microsoft.com/office/drawing/2014/main" id="{61E611A3-2434-4FD5-A987-EC519237E8C3}"/>
               </a:ext>
             </a:extLst>
           </p:cNvPr>
@@ -9503,7 +9325,7 @@
     </p:spTree>
     <p:extLst>
       <p:ext uri="{BB962C8B-B14F-4D97-AF65-F5344CB8AC3E}">
-        <p14:creationId xmlns:p14="http://schemas.microsoft.com/office/powerpoint/2010/main" val="795084446"/>
+        <p14:creationId xmlns:p14="http://schemas.microsoft.com/office/powerpoint/2010/main" val="1827692272"/>
       </p:ext>
     </p:extLst>
   </p:cSld>
@@ -9534,7 +9356,7 @@
           <p:cNvPr id="4" name="title">
             <a:extLst xmlns:a="http://schemas.openxmlformats.org/drawingml/2006/main">
               <a:ext uri="{FF2B5EF4-FFF2-40B4-BE49-F238E27FC236}">
-                <a16:creationId xmlns:a16="http://schemas.microsoft.com/office/drawing/2014/main" id="{A5311E02-0CFA-460B-A998-C571FA51F9F4}"/>
+                <a16:creationId xmlns:a16="http://schemas.microsoft.com/office/drawing/2014/main" id="{FD3C233B-D8E4-4363-A381-63614137D464}"/>
               </a:ext>
             </a:extLst>
           </p:cNvPr>
@@ -9690,7 +9512,7 @@
           <p:cNvPr id="2" name="body">
             <a:extLst xmlns:a="http://schemas.openxmlformats.org/drawingml/2006/main">
               <a:ext uri="{FF2B5EF4-FFF2-40B4-BE49-F238E27FC236}">
-                <a16:creationId xmlns:a16="http://schemas.microsoft.com/office/drawing/2014/main" id="{63D0C788-A9D0-4D09-9729-F268EA19078E}"/>
+                <a16:creationId xmlns:a16="http://schemas.microsoft.com/office/drawing/2014/main" id="{C52FF84C-A5E6-4C5F-9A2A-9C1C5445E43B}"/>
               </a:ext>
             </a:extLst>
           </p:cNvPr>
@@ -9920,7 +9742,7 @@
           <p:cNvPr id="3" name="page">
             <a:extLst xmlns:a="http://schemas.openxmlformats.org/drawingml/2006/main">
               <a:ext uri="{FF2B5EF4-FFF2-40B4-BE49-F238E27FC236}">
-                <a16:creationId xmlns:a16="http://schemas.microsoft.com/office/drawing/2014/main" id="{336B174C-4CDD-4240-AB4B-C28CA051FD90}"/>
+                <a16:creationId xmlns:a16="http://schemas.microsoft.com/office/drawing/2014/main" id="{D19ABCAD-813E-4596-BD0A-2B60DC1CF562}"/>
               </a:ext>
             </a:extLst>
           </p:cNvPr>
@@ -10074,7 +9896,7 @@
     </p:spTree>
     <p:extLst>
       <p:ext uri="{BB962C8B-B14F-4D97-AF65-F5344CB8AC3E}">
-        <p14:creationId xmlns:p14="http://schemas.microsoft.com/office/powerpoint/2010/main" val="592703895"/>
+        <p14:creationId xmlns:p14="http://schemas.microsoft.com/office/powerpoint/2010/main" val="937508036"/>
       </p:ext>
     </p:extLst>
   </p:cSld>
@@ -10105,7 +9927,7 @@
           <p:cNvPr id="4" name="title">
             <a:extLst xmlns:a="http://schemas.openxmlformats.org/drawingml/2006/main">
               <a:ext uri="{FF2B5EF4-FFF2-40B4-BE49-F238E27FC236}">
-                <a16:creationId xmlns:a16="http://schemas.microsoft.com/office/drawing/2014/main" id="{69852EBC-E6A1-4513-A0D6-50ABA139378E}"/>
+                <a16:creationId xmlns:a16="http://schemas.microsoft.com/office/drawing/2014/main" id="{9862AAC1-FFEC-430D-A538-4BD700FDFFAD}"/>
               </a:ext>
             </a:extLst>
           </p:cNvPr>
@@ -10261,7 +10083,7 @@
           <p:cNvPr id="2" name="body">
             <a:extLst xmlns:a="http://schemas.openxmlformats.org/drawingml/2006/main">
               <a:ext uri="{FF2B5EF4-FFF2-40B4-BE49-F238E27FC236}">
-                <a16:creationId xmlns:a16="http://schemas.microsoft.com/office/drawing/2014/main" id="{62DD0EFA-C037-4BC6-AD4D-973491A17ABF}"/>
+                <a16:creationId xmlns:a16="http://schemas.microsoft.com/office/drawing/2014/main" id="{F1AA9274-2B35-4E59-AB39-6F9C7D4B6A3C}"/>
               </a:ext>
             </a:extLst>
           </p:cNvPr>
@@ -10491,7 +10313,7 @@
           <p:cNvPr id="3" name="page">
             <a:extLst xmlns:a="http://schemas.openxmlformats.org/drawingml/2006/main">
               <a:ext uri="{FF2B5EF4-FFF2-40B4-BE49-F238E27FC236}">
-                <a16:creationId xmlns:a16="http://schemas.microsoft.com/office/drawing/2014/main" id="{F2B0EBC5-FAE3-46FB-8E93-11A48F11EE73}"/>
+                <a16:creationId xmlns:a16="http://schemas.microsoft.com/office/drawing/2014/main" id="{02D8BF04-4A0F-4D17-8042-F49FAB21A608}"/>
               </a:ext>
             </a:extLst>
           </p:cNvPr>
@@ -10645,7 +10467,7 @@
     </p:spTree>
     <p:extLst>
       <p:ext uri="{BB962C8B-B14F-4D97-AF65-F5344CB8AC3E}">
-        <p14:creationId xmlns:p14="http://schemas.microsoft.com/office/powerpoint/2010/main" val="1526411948"/>
+        <p14:creationId xmlns:p14="http://schemas.microsoft.com/office/powerpoint/2010/main" val="624341756"/>
       </p:ext>
     </p:extLst>
   </p:cSld>
@@ -10676,7 +10498,7 @@
           <p:cNvPr id="4" name="title">
             <a:extLst xmlns:a="http://schemas.openxmlformats.org/drawingml/2006/main">
               <a:ext uri="{FF2B5EF4-FFF2-40B4-BE49-F238E27FC236}">
-                <a16:creationId xmlns:a16="http://schemas.microsoft.com/office/drawing/2014/main" id="{F4CAE400-78B6-4EA1-B81E-4DB21AC9BA4E}"/>
+                <a16:creationId xmlns:a16="http://schemas.microsoft.com/office/drawing/2014/main" id="{C7ACC409-CC69-4A5B-BB6E-57B6031D08CA}"/>
               </a:ext>
             </a:extLst>
           </p:cNvPr>
@@ -10832,7 +10654,7 @@
           <p:cNvPr id="2" name="body">
             <a:extLst xmlns:a="http://schemas.openxmlformats.org/drawingml/2006/main">
               <a:ext uri="{FF2B5EF4-FFF2-40B4-BE49-F238E27FC236}">
-                <a16:creationId xmlns:a16="http://schemas.microsoft.com/office/drawing/2014/main" id="{8823C5D5-41A3-4065-B2A2-CCDC0FC747B3}"/>
+                <a16:creationId xmlns:a16="http://schemas.microsoft.com/office/drawing/2014/main" id="{ED9D24CC-3861-4152-B3FA-3D473E0842C7}"/>
               </a:ext>
             </a:extLst>
           </p:cNvPr>
@@ -10988,7 +10810,7 @@
           <p:cNvPr id="3" name="page">
             <a:extLst xmlns:a="http://schemas.openxmlformats.org/drawingml/2006/main">
               <a:ext uri="{FF2B5EF4-FFF2-40B4-BE49-F238E27FC236}">
-                <a16:creationId xmlns:a16="http://schemas.microsoft.com/office/drawing/2014/main" id="{FB6B1282-DCE2-46DA-807F-60C8A9348F2E}"/>
+                <a16:creationId xmlns:a16="http://schemas.microsoft.com/office/drawing/2014/main" id="{1C78861E-7DFD-4104-A657-CE8FBEFF4587}"/>
               </a:ext>
             </a:extLst>
           </p:cNvPr>
@@ -11142,7 +10964,7 @@
     </p:spTree>
     <p:extLst>
       <p:ext uri="{BB962C8B-B14F-4D97-AF65-F5344CB8AC3E}">
-        <p14:creationId xmlns:p14="http://schemas.microsoft.com/office/powerpoint/2010/main" val="2116270094"/>
+        <p14:creationId xmlns:p14="http://schemas.microsoft.com/office/powerpoint/2010/main" val="318674688"/>
       </p:ext>
     </p:extLst>
   </p:cSld>
@@ -11173,7 +10995,7 @@
           <p:cNvPr id="4" name="title">
             <a:extLst xmlns:a="http://schemas.openxmlformats.org/drawingml/2006/main">
               <a:ext uri="{FF2B5EF4-FFF2-40B4-BE49-F238E27FC236}">
-                <a16:creationId xmlns:a16="http://schemas.microsoft.com/office/drawing/2014/main" id="{4F185828-5927-4DCA-B9BC-360C9E8EBC9F}"/>
+                <a16:creationId xmlns:a16="http://schemas.microsoft.com/office/drawing/2014/main" id="{CC3ED03F-13DA-4C2B-88E4-42DAF3A6BA79}"/>
               </a:ext>
             </a:extLst>
           </p:cNvPr>
@@ -11329,7 +11151,7 @@
           <p:cNvPr id="2" name="body">
             <a:extLst xmlns:a="http://schemas.openxmlformats.org/drawingml/2006/main">
               <a:ext uri="{FF2B5EF4-FFF2-40B4-BE49-F238E27FC236}">
-                <a16:creationId xmlns:a16="http://schemas.microsoft.com/office/drawing/2014/main" id="{4F60C0CA-B485-447E-A73C-5F2E4B340D6A}"/>
+                <a16:creationId xmlns:a16="http://schemas.microsoft.com/office/drawing/2014/main" id="{4161F8B5-C60A-4D33-976B-9A930EC9334B}"/>
               </a:ext>
             </a:extLst>
           </p:cNvPr>
@@ -11582,7 +11404,7 @@
           <p:cNvPr id="3" name="page">
             <a:extLst xmlns:a="http://schemas.openxmlformats.org/drawingml/2006/main">
               <a:ext uri="{FF2B5EF4-FFF2-40B4-BE49-F238E27FC236}">
-                <a16:creationId xmlns:a16="http://schemas.microsoft.com/office/drawing/2014/main" id="{8C30701F-C993-449E-A63C-C533299E352B}"/>
+                <a16:creationId xmlns:a16="http://schemas.microsoft.com/office/drawing/2014/main" id="{5B53C7F3-3423-4A48-A5D7-60EA52BD0FBC}"/>
               </a:ext>
             </a:extLst>
           </p:cNvPr>
@@ -11736,7 +11558,7 @@
     </p:spTree>
     <p:extLst>
       <p:ext uri="{BB962C8B-B14F-4D97-AF65-F5344CB8AC3E}">
-        <p14:creationId xmlns:p14="http://schemas.microsoft.com/office/powerpoint/2010/main" val="1157922755"/>
+        <p14:creationId xmlns:p14="http://schemas.microsoft.com/office/powerpoint/2010/main" val="1427850948"/>
       </p:ext>
     </p:extLst>
   </p:cSld>
@@ -11767,7 +11589,7 @@
           <p:cNvPr id="4" name="title">
             <a:extLst xmlns:a="http://schemas.openxmlformats.org/drawingml/2006/main">
               <a:ext uri="{FF2B5EF4-FFF2-40B4-BE49-F238E27FC236}">
-                <a16:creationId xmlns:a16="http://schemas.microsoft.com/office/drawing/2014/main" id="{B4298215-51B6-48E7-9A5D-D48B07C20550}"/>
+                <a16:creationId xmlns:a16="http://schemas.microsoft.com/office/drawing/2014/main" id="{45254D1B-BDB8-4F3B-A5BE-92A39F164D6C}"/>
               </a:ext>
             </a:extLst>
           </p:cNvPr>
@@ -11923,7 +11745,7 @@
           <p:cNvPr id="2" name="body">
             <a:extLst xmlns:a="http://schemas.openxmlformats.org/drawingml/2006/main">
               <a:ext uri="{FF2B5EF4-FFF2-40B4-BE49-F238E27FC236}">
-                <a16:creationId xmlns:a16="http://schemas.microsoft.com/office/drawing/2014/main" id="{F7061039-2FF2-44F7-83EC-10BC4761F089}"/>
+                <a16:creationId xmlns:a16="http://schemas.microsoft.com/office/drawing/2014/main" id="{E5BEC2A9-3B89-45B8-B2BA-E3E15F96F40D}"/>
               </a:ext>
             </a:extLst>
           </p:cNvPr>
@@ -12153,7 +11975,7 @@
           <p:cNvPr id="3" name="page">
             <a:extLst xmlns:a="http://schemas.openxmlformats.org/drawingml/2006/main">
               <a:ext uri="{FF2B5EF4-FFF2-40B4-BE49-F238E27FC236}">
-                <a16:creationId xmlns:a16="http://schemas.microsoft.com/office/drawing/2014/main" id="{DE585645-920A-4718-8587-29D391720F98}"/>
+                <a16:creationId xmlns:a16="http://schemas.microsoft.com/office/drawing/2014/main" id="{D8852288-9947-433E-85AB-EBC22900EF00}"/>
               </a:ext>
             </a:extLst>
           </p:cNvPr>
@@ -12307,7 +12129,7 @@
     </p:spTree>
     <p:extLst>
       <p:ext uri="{BB962C8B-B14F-4D97-AF65-F5344CB8AC3E}">
-        <p14:creationId xmlns:p14="http://schemas.microsoft.com/office/powerpoint/2010/main" val="980051795"/>
+        <p14:creationId xmlns:p14="http://schemas.microsoft.com/office/powerpoint/2010/main" val="325299872"/>
       </p:ext>
     </p:extLst>
   </p:cSld>
@@ -12338,7 +12160,7 @@
           <p:cNvPr id="4" name="title">
             <a:extLst xmlns:a="http://schemas.openxmlformats.org/drawingml/2006/main">
               <a:ext uri="{FF2B5EF4-FFF2-40B4-BE49-F238E27FC236}">
-                <a16:creationId xmlns:a16="http://schemas.microsoft.com/office/drawing/2014/main" id="{D21C54B6-F150-42AB-86AD-5FFA2154CD08}"/>
+                <a16:creationId xmlns:a16="http://schemas.microsoft.com/office/drawing/2014/main" id="{7C7E09FE-885D-493C-9353-B7F6782754FC}"/>
               </a:ext>
             </a:extLst>
           </p:cNvPr>
@@ -12494,7 +12316,7 @@
           <p:cNvPr id="2" name="body">
             <a:extLst xmlns:a="http://schemas.openxmlformats.org/drawingml/2006/main">
               <a:ext uri="{FF2B5EF4-FFF2-40B4-BE49-F238E27FC236}">
-                <a16:creationId xmlns:a16="http://schemas.microsoft.com/office/drawing/2014/main" id="{81DC6D1A-C777-492F-8133-DCE5DFCB9171}"/>
+                <a16:creationId xmlns:a16="http://schemas.microsoft.com/office/drawing/2014/main" id="{B9B2DE59-A7EC-4AFD-993C-248052D1F2C0}"/>
               </a:ext>
             </a:extLst>
           </p:cNvPr>
@@ -12747,7 +12569,7 @@
           <p:cNvPr id="3" name="page">
             <a:extLst xmlns:a="http://schemas.openxmlformats.org/drawingml/2006/main">
               <a:ext uri="{FF2B5EF4-FFF2-40B4-BE49-F238E27FC236}">
-                <a16:creationId xmlns:a16="http://schemas.microsoft.com/office/drawing/2014/main" id="{F26F9E86-0851-4038-9879-A7A814A9F814}"/>
+                <a16:creationId xmlns:a16="http://schemas.microsoft.com/office/drawing/2014/main" id="{D3B3E0D3-58E4-43CE-87E5-FD3CC0387EA6}"/>
               </a:ext>
             </a:extLst>
           </p:cNvPr>
@@ -12901,7 +12723,7 @@
     </p:spTree>
     <p:extLst>
       <p:ext uri="{BB962C8B-B14F-4D97-AF65-F5344CB8AC3E}">
-        <p14:creationId xmlns:p14="http://schemas.microsoft.com/office/powerpoint/2010/main" val="1427007195"/>
+        <p14:creationId xmlns:p14="http://schemas.microsoft.com/office/powerpoint/2010/main" val="848648938"/>
       </p:ext>
     </p:extLst>
   </p:cSld>
@@ -12932,7 +12754,7 @@
           <p:cNvPr id="4" name="title">
             <a:extLst xmlns:a="http://schemas.openxmlformats.org/drawingml/2006/main">
               <a:ext uri="{FF2B5EF4-FFF2-40B4-BE49-F238E27FC236}">
-                <a16:creationId xmlns:a16="http://schemas.microsoft.com/office/drawing/2014/main" id="{62F1BB4F-3E2C-4E38-924B-AF271D539D5F}"/>
+                <a16:creationId xmlns:a16="http://schemas.microsoft.com/office/drawing/2014/main" id="{FF19DAF3-A8E6-4726-BA39-5CB661D7D2B1}"/>
               </a:ext>
             </a:extLst>
           </p:cNvPr>
@@ -13088,7 +12910,7 @@
           <p:cNvPr id="2" name="body">
             <a:extLst xmlns:a="http://schemas.openxmlformats.org/drawingml/2006/main">
               <a:ext uri="{FF2B5EF4-FFF2-40B4-BE49-F238E27FC236}">
-                <a16:creationId xmlns:a16="http://schemas.microsoft.com/office/drawing/2014/main" id="{2DE419C0-03D1-4802-9573-B7285129AA38}"/>
+                <a16:creationId xmlns:a16="http://schemas.microsoft.com/office/drawing/2014/main" id="{863626A2-B90A-490F-9BF2-EA84DAE36532}"/>
               </a:ext>
             </a:extLst>
           </p:cNvPr>
@@ -13341,7 +13163,7 @@
           <p:cNvPr id="3" name="page">
             <a:extLst xmlns:a="http://schemas.openxmlformats.org/drawingml/2006/main">
               <a:ext uri="{FF2B5EF4-FFF2-40B4-BE49-F238E27FC236}">
-                <a16:creationId xmlns:a16="http://schemas.microsoft.com/office/drawing/2014/main" id="{6020FD1A-345F-499B-9F1D-85906803CDC3}"/>
+                <a16:creationId xmlns:a16="http://schemas.microsoft.com/office/drawing/2014/main" id="{604EC1AC-A1AD-4170-BA63-AB021D8A3364}"/>
               </a:ext>
             </a:extLst>
           </p:cNvPr>
@@ -13495,7 +13317,7 @@
     </p:spTree>
     <p:extLst>
       <p:ext uri="{BB962C8B-B14F-4D97-AF65-F5344CB8AC3E}">
-        <p14:creationId xmlns:p14="http://schemas.microsoft.com/office/powerpoint/2010/main" val="1316742588"/>
+        <p14:creationId xmlns:p14="http://schemas.microsoft.com/office/powerpoint/2010/main" val="757255572"/>
       </p:ext>
     </p:extLst>
   </p:cSld>
@@ -13526,7 +13348,7 @@
           <p:cNvPr id="4" name="title">
             <a:extLst xmlns:a="http://schemas.openxmlformats.org/drawingml/2006/main">
               <a:ext uri="{FF2B5EF4-FFF2-40B4-BE49-F238E27FC236}">
-                <a16:creationId xmlns:a16="http://schemas.microsoft.com/office/drawing/2014/main" id="{6E9ED4AD-0C63-4C5A-BE88-412D947F1DD8}"/>
+                <a16:creationId xmlns:a16="http://schemas.microsoft.com/office/drawing/2014/main" id="{7C683CB2-8756-48AD-A0DA-762C74D01C36}"/>
               </a:ext>
             </a:extLst>
           </p:cNvPr>
@@ -13682,7 +13504,7 @@
           <p:cNvPr id="2" name="body">
             <a:extLst xmlns:a="http://schemas.openxmlformats.org/drawingml/2006/main">
               <a:ext uri="{FF2B5EF4-FFF2-40B4-BE49-F238E27FC236}">
-                <a16:creationId xmlns:a16="http://schemas.microsoft.com/office/drawing/2014/main" id="{08F32B51-6E9E-405D-B128-1EAACCAC4439}"/>
+                <a16:creationId xmlns:a16="http://schemas.microsoft.com/office/drawing/2014/main" id="{D19EFD46-BF30-46D9-B08A-F84B8A0E3A70}"/>
               </a:ext>
             </a:extLst>
           </p:cNvPr>
@@ -13935,7 +13757,7 @@
           <p:cNvPr id="3" name="page">
             <a:extLst xmlns:a="http://schemas.openxmlformats.org/drawingml/2006/main">
               <a:ext uri="{FF2B5EF4-FFF2-40B4-BE49-F238E27FC236}">
-                <a16:creationId xmlns:a16="http://schemas.microsoft.com/office/drawing/2014/main" id="{4C5F1A76-5292-4684-946E-DCA80F76BD8C}"/>
+                <a16:creationId xmlns:a16="http://schemas.microsoft.com/office/drawing/2014/main" id="{A8591354-F5B8-4BF4-8D05-5169B813DA9C}"/>
               </a:ext>
             </a:extLst>
           </p:cNvPr>
@@ -14089,7 +13911,7 @@
     </p:spTree>
     <p:extLst>
       <p:ext uri="{BB962C8B-B14F-4D97-AF65-F5344CB8AC3E}">
-        <p14:creationId xmlns:p14="http://schemas.microsoft.com/office/powerpoint/2010/main" val="166176805"/>
+        <p14:creationId xmlns:p14="http://schemas.microsoft.com/office/powerpoint/2010/main" val="712065131"/>
       </p:ext>
     </p:extLst>
   </p:cSld>
@@ -14120,7 +13942,7 @@
           <p:cNvPr id="4" name="title">
             <a:extLst xmlns:a="http://schemas.openxmlformats.org/drawingml/2006/main">
               <a:ext uri="{FF2B5EF4-FFF2-40B4-BE49-F238E27FC236}">
-                <a16:creationId xmlns:a16="http://schemas.microsoft.com/office/drawing/2014/main" id="{0CD41C30-84A9-4465-B5D9-8BFD2A065DA5}"/>
+                <a16:creationId xmlns:a16="http://schemas.microsoft.com/office/drawing/2014/main" id="{1B01AF96-87E4-452B-85C3-770275F02D02}"/>
               </a:ext>
             </a:extLst>
           </p:cNvPr>
@@ -14276,7 +14098,7 @@
           <p:cNvPr id="2" name="body">
             <a:extLst xmlns:a="http://schemas.openxmlformats.org/drawingml/2006/main">
               <a:ext uri="{FF2B5EF4-FFF2-40B4-BE49-F238E27FC236}">
-                <a16:creationId xmlns:a16="http://schemas.microsoft.com/office/drawing/2014/main" id="{3341E3CE-F545-490B-846B-5C24AFAAAB71}"/>
+                <a16:creationId xmlns:a16="http://schemas.microsoft.com/office/drawing/2014/main" id="{B88E6DF4-E40E-4F8E-8205-CF902F1F53C8}"/>
               </a:ext>
             </a:extLst>
           </p:cNvPr>
@@ -14422,7 +14244,7 @@
                 <a:ea typeface="Arial"/>
                 <a:cs typeface="Arial"/>
               </a:rPr>
-              <a:t>Osoba namjerno započne običan razgovor u namazu. Šta taj govor kvari?</a:t>
+              <a:t>Koji par najbolje razlikuje obavezu i preporučeno djelo?</a:t>
             </a:r>
           </a:p>
           <a:p xmlns:a="http://schemas.openxmlformats.org/drawingml/2006/main">
@@ -14450,7 +14272,7 @@
                 <a:ea typeface="Arial"/>
                 <a:cs typeface="Arial"/>
               </a:rPr>
-              <a:t>A   Namaz, ali sam po sebi ne abdest</a:t>
+              <a:t>A   Farz — stroga dužnost; mustehab — preporučeno djelo</a:t>
             </a:r>
           </a:p>
           <a:p xmlns:a="http://schemas.openxmlformats.org/drawingml/2006/main">
@@ -14473,7 +14295,7 @@
                 <a:ea typeface="Arial"/>
                 <a:cs typeface="Arial"/>
               </a:rPr>
-              <a:t>B   Samo abdest</a:t>
+              <a:t>B   Mubah — stroga dužnost; haram — preporuka</a:t>
             </a:r>
           </a:p>
           <a:p xmlns:a="http://schemas.openxmlformats.org/drawingml/2006/main">
@@ -14496,7 +14318,7 @@
                 <a:ea typeface="Arial"/>
                 <a:cs typeface="Arial"/>
               </a:rPr>
-              <a:t>C   I namaz i abdest u svakom slučaju</a:t>
+              <a:t>C   Sunnet — stroga zabrana; farz — izbor</a:t>
             </a:r>
           </a:p>
           <a:p xmlns:a="http://schemas.openxmlformats.org/drawingml/2006/main">
@@ -14519,7 +14341,7 @@
                 <a:ea typeface="Arial"/>
                 <a:cs typeface="Arial"/>
               </a:rPr>
-              <a:t>D   Ni namaz ni abdest</a:t>
+              <a:t>D   Mekruh — obaveza; vadžib — slobodan izbor</a:t>
             </a:r>
           </a:p>
         </p:txBody>
@@ -14529,7 +14351,7 @@
           <p:cNvPr id="3" name="page">
             <a:extLst xmlns:a="http://schemas.openxmlformats.org/drawingml/2006/main">
               <a:ext uri="{FF2B5EF4-FFF2-40B4-BE49-F238E27FC236}">
-                <a16:creationId xmlns:a16="http://schemas.microsoft.com/office/drawing/2014/main" id="{21BDC075-304C-45F8-88D5-0141BE482CC9}"/>
+                <a16:creationId xmlns:a16="http://schemas.microsoft.com/office/drawing/2014/main" id="{ABE694D5-F89B-43EC-AF02-B79B32D86431}"/>
               </a:ext>
             </a:extLst>
           </p:cNvPr>
@@ -14683,7 +14505,7 @@
     </p:spTree>
     <p:extLst>
       <p:ext uri="{BB962C8B-B14F-4D97-AF65-F5344CB8AC3E}">
-        <p14:creationId xmlns:p14="http://schemas.microsoft.com/office/powerpoint/2010/main" val="1910611052"/>
+        <p14:creationId xmlns:p14="http://schemas.microsoft.com/office/powerpoint/2010/main" val="1145252741"/>
       </p:ext>
     </p:extLst>
   </p:cSld>
@@ -14714,7 +14536,7 @@
           <p:cNvPr id="4" name="title">
             <a:extLst xmlns:a="http://schemas.openxmlformats.org/drawingml/2006/main">
               <a:ext uri="{FF2B5EF4-FFF2-40B4-BE49-F238E27FC236}">
-                <a16:creationId xmlns:a16="http://schemas.microsoft.com/office/drawing/2014/main" id="{7356B942-1046-4E71-AA77-C0BAC50C3EA0}"/>
+                <a16:creationId xmlns:a16="http://schemas.microsoft.com/office/drawing/2014/main" id="{7FB960EC-6493-4E72-B4A8-B28E553040D3}"/>
               </a:ext>
             </a:extLst>
           </p:cNvPr>
@@ -14870,7 +14692,7 @@
           <p:cNvPr id="2" name="body">
             <a:extLst xmlns:a="http://schemas.openxmlformats.org/drawingml/2006/main">
               <a:ext uri="{FF2B5EF4-FFF2-40B4-BE49-F238E27FC236}">
-                <a16:creationId xmlns:a16="http://schemas.microsoft.com/office/drawing/2014/main" id="{1E6B1BFE-E0BE-43AA-AC14-65D53874B7EC}"/>
+                <a16:creationId xmlns:a16="http://schemas.microsoft.com/office/drawing/2014/main" id="{49C17089-6311-4322-9677-6840F7D42D7F}"/>
               </a:ext>
             </a:extLst>
           </p:cNvPr>
@@ -15123,7 +14945,7 @@
           <p:cNvPr id="3" name="page">
             <a:extLst xmlns:a="http://schemas.openxmlformats.org/drawingml/2006/main">
               <a:ext uri="{FF2B5EF4-FFF2-40B4-BE49-F238E27FC236}">
-                <a16:creationId xmlns:a16="http://schemas.microsoft.com/office/drawing/2014/main" id="{2F024E10-70DC-492D-AEC5-E4DEE947FC8F}"/>
+                <a16:creationId xmlns:a16="http://schemas.microsoft.com/office/drawing/2014/main" id="{9833804B-4F48-4E82-A45B-1BE90399A914}"/>
               </a:ext>
             </a:extLst>
           </p:cNvPr>
@@ -15277,7 +15099,7 @@
     </p:spTree>
     <p:extLst>
       <p:ext uri="{BB962C8B-B14F-4D97-AF65-F5344CB8AC3E}">
-        <p14:creationId xmlns:p14="http://schemas.microsoft.com/office/powerpoint/2010/main" val="725293734"/>
+        <p14:creationId xmlns:p14="http://schemas.microsoft.com/office/powerpoint/2010/main" val="425655790"/>
       </p:ext>
     </p:extLst>
   </p:cSld>
@@ -15308,7 +15130,7 @@
           <p:cNvPr id="4" name="title">
             <a:extLst xmlns:a="http://schemas.openxmlformats.org/drawingml/2006/main">
               <a:ext uri="{FF2B5EF4-FFF2-40B4-BE49-F238E27FC236}">
-                <a16:creationId xmlns:a16="http://schemas.microsoft.com/office/drawing/2014/main" id="{4A901681-828D-401C-B48F-D1F9F33E4E1D}"/>
+                <a16:creationId xmlns:a16="http://schemas.microsoft.com/office/drawing/2014/main" id="{1E6B04DF-E68E-4255-82B0-4E291341C308}"/>
               </a:ext>
             </a:extLst>
           </p:cNvPr>
@@ -15464,7 +15286,7 @@
           <p:cNvPr id="2" name="body">
             <a:extLst xmlns:a="http://schemas.openxmlformats.org/drawingml/2006/main">
               <a:ext uri="{FF2B5EF4-FFF2-40B4-BE49-F238E27FC236}">
-                <a16:creationId xmlns:a16="http://schemas.microsoft.com/office/drawing/2014/main" id="{5C78A77E-35A7-4207-9165-8ABEA0379294}"/>
+                <a16:creationId xmlns:a16="http://schemas.microsoft.com/office/drawing/2014/main" id="{D94B7177-659D-4A29-861A-6C8C26A51371}"/>
               </a:ext>
             </a:extLst>
           </p:cNvPr>
@@ -15717,7 +15539,7 @@
           <p:cNvPr id="3" name="page">
             <a:extLst xmlns:a="http://schemas.openxmlformats.org/drawingml/2006/main">
               <a:ext uri="{FF2B5EF4-FFF2-40B4-BE49-F238E27FC236}">
-                <a16:creationId xmlns:a16="http://schemas.microsoft.com/office/drawing/2014/main" id="{88A6A070-4080-4156-A55B-46CFB6BF483C}"/>
+                <a16:creationId xmlns:a16="http://schemas.microsoft.com/office/drawing/2014/main" id="{048E8954-9E61-4734-878E-3BD3BBE48F7A}"/>
               </a:ext>
             </a:extLst>
           </p:cNvPr>
@@ -15871,7 +15693,7 @@
     </p:spTree>
     <p:extLst>
       <p:ext uri="{BB962C8B-B14F-4D97-AF65-F5344CB8AC3E}">
-        <p14:creationId xmlns:p14="http://schemas.microsoft.com/office/powerpoint/2010/main" val="1639965558"/>
+        <p14:creationId xmlns:p14="http://schemas.microsoft.com/office/powerpoint/2010/main" val="299105177"/>
       </p:ext>
     </p:extLst>
   </p:cSld>
@@ -15902,7 +15724,7 @@
           <p:cNvPr id="4" name="title">
             <a:extLst xmlns:a="http://schemas.openxmlformats.org/drawingml/2006/main">
               <a:ext uri="{FF2B5EF4-FFF2-40B4-BE49-F238E27FC236}">
-                <a16:creationId xmlns:a16="http://schemas.microsoft.com/office/drawing/2014/main" id="{A8758C02-EA61-4328-8343-E8FEA6827349}"/>
+                <a16:creationId xmlns:a16="http://schemas.microsoft.com/office/drawing/2014/main" id="{3A8B8665-8BA9-4C36-92EB-2A84F28D9176}"/>
               </a:ext>
             </a:extLst>
           </p:cNvPr>
@@ -16058,7 +15880,7 @@
           <p:cNvPr id="2" name="body">
             <a:extLst xmlns:a="http://schemas.openxmlformats.org/drawingml/2006/main">
               <a:ext uri="{FF2B5EF4-FFF2-40B4-BE49-F238E27FC236}">
-                <a16:creationId xmlns:a16="http://schemas.microsoft.com/office/drawing/2014/main" id="{0E1E042D-AD5F-428C-83EC-2BBE85B9367C}"/>
+                <a16:creationId xmlns:a16="http://schemas.microsoft.com/office/drawing/2014/main" id="{1BC03DD2-D24A-4B28-A37D-6C51DCF7151C}"/>
               </a:ext>
             </a:extLst>
           </p:cNvPr>
@@ -16311,7 +16133,7 @@
           <p:cNvPr id="3" name="page">
             <a:extLst xmlns:a="http://schemas.openxmlformats.org/drawingml/2006/main">
               <a:ext uri="{FF2B5EF4-FFF2-40B4-BE49-F238E27FC236}">
-                <a16:creationId xmlns:a16="http://schemas.microsoft.com/office/drawing/2014/main" id="{E9393C40-F3AC-429A-8892-F27359846854}"/>
+                <a16:creationId xmlns:a16="http://schemas.microsoft.com/office/drawing/2014/main" id="{4F2144BD-EB70-4336-97A5-BA815FF4D129}"/>
               </a:ext>
             </a:extLst>
           </p:cNvPr>
@@ -16465,7 +16287,7 @@
     </p:spTree>
     <p:extLst>
       <p:ext uri="{BB962C8B-B14F-4D97-AF65-F5344CB8AC3E}">
-        <p14:creationId xmlns:p14="http://schemas.microsoft.com/office/powerpoint/2010/main" val="2064980066"/>
+        <p14:creationId xmlns:p14="http://schemas.microsoft.com/office/powerpoint/2010/main" val="614134359"/>
       </p:ext>
     </p:extLst>
   </p:cSld>
@@ -16496,7 +16318,7 @@
           <p:cNvPr id="4" name="title">
             <a:extLst xmlns:a="http://schemas.openxmlformats.org/drawingml/2006/main">
               <a:ext uri="{FF2B5EF4-FFF2-40B4-BE49-F238E27FC236}">
-                <a16:creationId xmlns:a16="http://schemas.microsoft.com/office/drawing/2014/main" id="{D0FBC09E-AB61-42FF-9FEA-335DA9538E3B}"/>
+                <a16:creationId xmlns:a16="http://schemas.microsoft.com/office/drawing/2014/main" id="{006E1C1D-E021-44D6-AEBE-2DFE8BD3ED74}"/>
               </a:ext>
             </a:extLst>
           </p:cNvPr>
@@ -16652,7 +16474,7 @@
           <p:cNvPr id="2" name="body">
             <a:extLst xmlns:a="http://schemas.openxmlformats.org/drawingml/2006/main">
               <a:ext uri="{FF2B5EF4-FFF2-40B4-BE49-F238E27FC236}">
-                <a16:creationId xmlns:a16="http://schemas.microsoft.com/office/drawing/2014/main" id="{354A693E-A552-4C05-88E0-8E4FA504C992}"/>
+                <a16:creationId xmlns:a16="http://schemas.microsoft.com/office/drawing/2014/main" id="{2702B299-16CA-411E-AF7B-38170526518F}"/>
               </a:ext>
             </a:extLst>
           </p:cNvPr>
@@ -16905,7 +16727,7 @@
           <p:cNvPr id="3" name="page">
             <a:extLst xmlns:a="http://schemas.openxmlformats.org/drawingml/2006/main">
               <a:ext uri="{FF2B5EF4-FFF2-40B4-BE49-F238E27FC236}">
-                <a16:creationId xmlns:a16="http://schemas.microsoft.com/office/drawing/2014/main" id="{8BFFA994-2EA6-45C6-88F0-EC6FCD8D90FB}"/>
+                <a16:creationId xmlns:a16="http://schemas.microsoft.com/office/drawing/2014/main" id="{4CA25172-47C0-47CD-A369-C49E1D74CE30}"/>
               </a:ext>
             </a:extLst>
           </p:cNvPr>
@@ -17059,7 +16881,7 @@
     </p:spTree>
     <p:extLst>
       <p:ext uri="{BB962C8B-B14F-4D97-AF65-F5344CB8AC3E}">
-        <p14:creationId xmlns:p14="http://schemas.microsoft.com/office/powerpoint/2010/main" val="1618751220"/>
+        <p14:creationId xmlns:p14="http://schemas.microsoft.com/office/powerpoint/2010/main" val="795886900"/>
       </p:ext>
     </p:extLst>
   </p:cSld>
@@ -17090,7 +16912,7 @@
           <p:cNvPr id="4" name="title">
             <a:extLst xmlns:a="http://schemas.openxmlformats.org/drawingml/2006/main">
               <a:ext uri="{FF2B5EF4-FFF2-40B4-BE49-F238E27FC236}">
-                <a16:creationId xmlns:a16="http://schemas.microsoft.com/office/drawing/2014/main" id="{84B6BF92-F246-466D-8B42-772511A0FFA3}"/>
+                <a16:creationId xmlns:a16="http://schemas.microsoft.com/office/drawing/2014/main" id="{996922BA-BB9B-479A-B2E5-FDDC4CF71A14}"/>
               </a:ext>
             </a:extLst>
           </p:cNvPr>
@@ -17246,7 +17068,7 @@
           <p:cNvPr id="2" name="body">
             <a:extLst xmlns:a="http://schemas.openxmlformats.org/drawingml/2006/main">
               <a:ext uri="{FF2B5EF4-FFF2-40B4-BE49-F238E27FC236}">
-                <a16:creationId xmlns:a16="http://schemas.microsoft.com/office/drawing/2014/main" id="{985B5CE1-AB94-4583-8CF3-4B2B586071B5}"/>
+                <a16:creationId xmlns:a16="http://schemas.microsoft.com/office/drawing/2014/main" id="{918C354A-694E-4C19-BEDC-8C759CC22D3E}"/>
               </a:ext>
             </a:extLst>
           </p:cNvPr>
@@ -17499,7 +17321,7 @@
           <p:cNvPr id="3" name="page">
             <a:extLst xmlns:a="http://schemas.openxmlformats.org/drawingml/2006/main">
               <a:ext uri="{FF2B5EF4-FFF2-40B4-BE49-F238E27FC236}">
-                <a16:creationId xmlns:a16="http://schemas.microsoft.com/office/drawing/2014/main" id="{3A84CD0F-8BFA-4CBF-A3DB-323A3363C4E1}"/>
+                <a16:creationId xmlns:a16="http://schemas.microsoft.com/office/drawing/2014/main" id="{C57A7A7D-7176-4F8A-9D4E-F3F89D2A6006}"/>
               </a:ext>
             </a:extLst>
           </p:cNvPr>
@@ -17653,7 +17475,7 @@
     </p:spTree>
     <p:extLst>
       <p:ext uri="{BB962C8B-B14F-4D97-AF65-F5344CB8AC3E}">
-        <p14:creationId xmlns:p14="http://schemas.microsoft.com/office/powerpoint/2010/main" val="160713765"/>
+        <p14:creationId xmlns:p14="http://schemas.microsoft.com/office/powerpoint/2010/main" val="1346082999"/>
       </p:ext>
     </p:extLst>
   </p:cSld>
@@ -17684,7 +17506,7 @@
           <p:cNvPr id="4" name="title">
             <a:extLst xmlns:a="http://schemas.openxmlformats.org/drawingml/2006/main">
               <a:ext uri="{FF2B5EF4-FFF2-40B4-BE49-F238E27FC236}">
-                <a16:creationId xmlns:a16="http://schemas.microsoft.com/office/drawing/2014/main" id="{4F4306DF-AAA0-4975-8939-29A18CE7918C}"/>
+                <a16:creationId xmlns:a16="http://schemas.microsoft.com/office/drawing/2014/main" id="{FE0820DE-0C7F-4627-AFE5-6B6453699C03}"/>
               </a:ext>
             </a:extLst>
           </p:cNvPr>
@@ -17840,7 +17662,7 @@
           <p:cNvPr id="2" name="body">
             <a:extLst xmlns:a="http://schemas.openxmlformats.org/drawingml/2006/main">
               <a:ext uri="{FF2B5EF4-FFF2-40B4-BE49-F238E27FC236}">
-                <a16:creationId xmlns:a16="http://schemas.microsoft.com/office/drawing/2014/main" id="{2587AC0A-04F5-4146-9698-5B4D0E8D43B5}"/>
+                <a16:creationId xmlns:a16="http://schemas.microsoft.com/office/drawing/2014/main" id="{C1D20B60-FF7F-4CC1-8E40-E9EA93F80946}"/>
               </a:ext>
             </a:extLst>
           </p:cNvPr>
@@ -18093,7 +17915,7 @@
           <p:cNvPr id="3" name="page">
             <a:extLst xmlns:a="http://schemas.openxmlformats.org/drawingml/2006/main">
               <a:ext uri="{FF2B5EF4-FFF2-40B4-BE49-F238E27FC236}">
-                <a16:creationId xmlns:a16="http://schemas.microsoft.com/office/drawing/2014/main" id="{9BA4BB34-3E06-496D-836D-DFDF2D4739EA}"/>
+                <a16:creationId xmlns:a16="http://schemas.microsoft.com/office/drawing/2014/main" id="{D527A8A0-9208-46BA-82BE-3F246D0D13C7}"/>
               </a:ext>
             </a:extLst>
           </p:cNvPr>
@@ -18247,7 +18069,7 @@
     </p:spTree>
     <p:extLst>
       <p:ext uri="{BB962C8B-B14F-4D97-AF65-F5344CB8AC3E}">
-        <p14:creationId xmlns:p14="http://schemas.microsoft.com/office/powerpoint/2010/main" val="563542416"/>
+        <p14:creationId xmlns:p14="http://schemas.microsoft.com/office/powerpoint/2010/main" val="374120913"/>
       </p:ext>
     </p:extLst>
   </p:cSld>
@@ -18278,7 +18100,7 @@
           <p:cNvPr id="4" name="title">
             <a:extLst xmlns:a="http://schemas.openxmlformats.org/drawingml/2006/main">
               <a:ext uri="{FF2B5EF4-FFF2-40B4-BE49-F238E27FC236}">
-                <a16:creationId xmlns:a16="http://schemas.microsoft.com/office/drawing/2014/main" id="{4F3B8589-A997-4097-830C-C6FDE37AC628}"/>
+                <a16:creationId xmlns:a16="http://schemas.microsoft.com/office/drawing/2014/main" id="{26AE110F-EDE5-4741-ADAC-209F252F6C29}"/>
               </a:ext>
             </a:extLst>
           </p:cNvPr>
@@ -18434,7 +18256,7 @@
           <p:cNvPr id="2" name="body">
             <a:extLst xmlns:a="http://schemas.openxmlformats.org/drawingml/2006/main">
               <a:ext uri="{FF2B5EF4-FFF2-40B4-BE49-F238E27FC236}">
-                <a16:creationId xmlns:a16="http://schemas.microsoft.com/office/drawing/2014/main" id="{FFBB45B1-208A-4A94-8F2A-B53976D402B7}"/>
+                <a16:creationId xmlns:a16="http://schemas.microsoft.com/office/drawing/2014/main" id="{974AE3DC-C8CA-4F66-810E-4C72ACC9EEF3}"/>
               </a:ext>
             </a:extLst>
           </p:cNvPr>
@@ -18618,7 +18440,7 @@
           <p:cNvPr id="3" name="page">
             <a:extLst xmlns:a="http://schemas.openxmlformats.org/drawingml/2006/main">
               <a:ext uri="{FF2B5EF4-FFF2-40B4-BE49-F238E27FC236}">
-                <a16:creationId xmlns:a16="http://schemas.microsoft.com/office/drawing/2014/main" id="{01A1BC9B-5C60-45F5-ADE7-23C396840354}"/>
+                <a16:creationId xmlns:a16="http://schemas.microsoft.com/office/drawing/2014/main" id="{CBBA6323-CB7B-44D6-92D5-03F272F13724}"/>
               </a:ext>
             </a:extLst>
           </p:cNvPr>
@@ -18772,7 +18594,7 @@
     </p:spTree>
     <p:extLst>
       <p:ext uri="{BB962C8B-B14F-4D97-AF65-F5344CB8AC3E}">
-        <p14:creationId xmlns:p14="http://schemas.microsoft.com/office/powerpoint/2010/main" val="676778024"/>
+        <p14:creationId xmlns:p14="http://schemas.microsoft.com/office/powerpoint/2010/main" val="306474620"/>
       </p:ext>
     </p:extLst>
   </p:cSld>
@@ -18803,7 +18625,7 @@
           <p:cNvPr id="4" name="title">
             <a:extLst xmlns:a="http://schemas.openxmlformats.org/drawingml/2006/main">
               <a:ext uri="{FF2B5EF4-FFF2-40B4-BE49-F238E27FC236}">
-                <a16:creationId xmlns:a16="http://schemas.microsoft.com/office/drawing/2014/main" id="{FFAE1C17-1D98-4DCD-922A-C10B29DA053C}"/>
+                <a16:creationId xmlns:a16="http://schemas.microsoft.com/office/drawing/2014/main" id="{401144D8-DEC4-441C-9AFE-C4849980EF3C}"/>
               </a:ext>
             </a:extLst>
           </p:cNvPr>
@@ -18959,7 +18781,7 @@
           <p:cNvPr id="2" name="body">
             <a:extLst xmlns:a="http://schemas.openxmlformats.org/drawingml/2006/main">
               <a:ext uri="{FF2B5EF4-FFF2-40B4-BE49-F238E27FC236}">
-                <a16:creationId xmlns:a16="http://schemas.microsoft.com/office/drawing/2014/main" id="{31B7F640-ADA3-4927-936A-590CAC34AEF0}"/>
+                <a16:creationId xmlns:a16="http://schemas.microsoft.com/office/drawing/2014/main" id="{1BC0095A-B8BE-4383-8191-51CAB8F02B2A}"/>
               </a:ext>
             </a:extLst>
           </p:cNvPr>
@@ -19212,7 +19034,7 @@
           <p:cNvPr id="3" name="page">
             <a:extLst xmlns:a="http://schemas.openxmlformats.org/drawingml/2006/main">
               <a:ext uri="{FF2B5EF4-FFF2-40B4-BE49-F238E27FC236}">
-                <a16:creationId xmlns:a16="http://schemas.microsoft.com/office/drawing/2014/main" id="{DEA5A433-F5AF-4BFC-882D-6EB99B0CA233}"/>
+                <a16:creationId xmlns:a16="http://schemas.microsoft.com/office/drawing/2014/main" id="{5EF9C1C4-8D55-4BDA-A35E-B3DEA4AB8CFC}"/>
               </a:ext>
             </a:extLst>
           </p:cNvPr>
@@ -19366,7 +19188,7 @@
     </p:spTree>
     <p:extLst>
       <p:ext uri="{BB962C8B-B14F-4D97-AF65-F5344CB8AC3E}">
-        <p14:creationId xmlns:p14="http://schemas.microsoft.com/office/powerpoint/2010/main" val="1036454187"/>
+        <p14:creationId xmlns:p14="http://schemas.microsoft.com/office/powerpoint/2010/main" val="1652142407"/>
       </p:ext>
     </p:extLst>
   </p:cSld>
@@ -19397,7 +19219,7 @@
           <p:cNvPr id="4" name="title">
             <a:extLst xmlns:a="http://schemas.openxmlformats.org/drawingml/2006/main">
               <a:ext uri="{FF2B5EF4-FFF2-40B4-BE49-F238E27FC236}">
-                <a16:creationId xmlns:a16="http://schemas.microsoft.com/office/drawing/2014/main" id="{8ABAAF96-898F-41FA-A783-510AD705FD78}"/>
+                <a16:creationId xmlns:a16="http://schemas.microsoft.com/office/drawing/2014/main" id="{3AD39ECF-64BD-4BBA-ABA9-844CFC4BC956}"/>
               </a:ext>
             </a:extLst>
           </p:cNvPr>
@@ -19553,7 +19375,7 @@
           <p:cNvPr id="2" name="body">
             <a:extLst xmlns:a="http://schemas.openxmlformats.org/drawingml/2006/main">
               <a:ext uri="{FF2B5EF4-FFF2-40B4-BE49-F238E27FC236}">
-                <a16:creationId xmlns:a16="http://schemas.microsoft.com/office/drawing/2014/main" id="{F48155CD-B8D3-46A5-9058-D0DF11FE4CE3}"/>
+                <a16:creationId xmlns:a16="http://schemas.microsoft.com/office/drawing/2014/main" id="{928463B4-4F8C-4EB6-8CBE-7FE00D2D0C7E}"/>
               </a:ext>
             </a:extLst>
           </p:cNvPr>
@@ -19737,7 +19559,7 @@
           <p:cNvPr id="3" name="page">
             <a:extLst xmlns:a="http://schemas.openxmlformats.org/drawingml/2006/main">
               <a:ext uri="{FF2B5EF4-FFF2-40B4-BE49-F238E27FC236}">
-                <a16:creationId xmlns:a16="http://schemas.microsoft.com/office/drawing/2014/main" id="{EA471B5E-C00B-4DAB-841D-CEA71AA5A412}"/>
+                <a16:creationId xmlns:a16="http://schemas.microsoft.com/office/drawing/2014/main" id="{D742FB6B-8477-4097-B737-EE96F86D7DE8}"/>
               </a:ext>
             </a:extLst>
           </p:cNvPr>
@@ -19891,7 +19713,7 @@
     </p:spTree>
     <p:extLst>
       <p:ext uri="{BB962C8B-B14F-4D97-AF65-F5344CB8AC3E}">
-        <p14:creationId xmlns:p14="http://schemas.microsoft.com/office/powerpoint/2010/main" val="1007368283"/>
+        <p14:creationId xmlns:p14="http://schemas.microsoft.com/office/powerpoint/2010/main" val="310981671"/>
       </p:ext>
     </p:extLst>
   </p:cSld>
@@ -19922,7 +19744,7 @@
           <p:cNvPr id="4" name="title">
             <a:extLst xmlns:a="http://schemas.openxmlformats.org/drawingml/2006/main">
               <a:ext uri="{FF2B5EF4-FFF2-40B4-BE49-F238E27FC236}">
-                <a16:creationId xmlns:a16="http://schemas.microsoft.com/office/drawing/2014/main" id="{3DCFCF87-708C-409C-8159-EED426769D62}"/>
+                <a16:creationId xmlns:a16="http://schemas.microsoft.com/office/drawing/2014/main" id="{3F170C81-70AD-4CD2-869A-EA8E0A960926}"/>
               </a:ext>
             </a:extLst>
           </p:cNvPr>
@@ -20078,7 +19900,7 @@
           <p:cNvPr id="2" name="body">
             <a:extLst xmlns:a="http://schemas.openxmlformats.org/drawingml/2006/main">
               <a:ext uri="{FF2B5EF4-FFF2-40B4-BE49-F238E27FC236}">
-                <a16:creationId xmlns:a16="http://schemas.microsoft.com/office/drawing/2014/main" id="{1F78F399-8202-4F5C-BF9F-5DAF3EC003A3}"/>
+                <a16:creationId xmlns:a16="http://schemas.microsoft.com/office/drawing/2014/main" id="{D7B6BEF4-6A90-4CC5-B540-FBF48BE4C0D3}"/>
               </a:ext>
             </a:extLst>
           </p:cNvPr>
@@ -20262,7 +20084,7 @@
           <p:cNvPr id="3" name="page">
             <a:extLst xmlns:a="http://schemas.openxmlformats.org/drawingml/2006/main">
               <a:ext uri="{FF2B5EF4-FFF2-40B4-BE49-F238E27FC236}">
-                <a16:creationId xmlns:a16="http://schemas.microsoft.com/office/drawing/2014/main" id="{FBC54772-B066-498B-B5ED-9D183AFD780E}"/>
+                <a16:creationId xmlns:a16="http://schemas.microsoft.com/office/drawing/2014/main" id="{D2B28582-5667-4D88-AED5-F5D49BA57ADB}"/>
               </a:ext>
             </a:extLst>
           </p:cNvPr>
@@ -20416,7 +20238,7 @@
     </p:spTree>
     <p:extLst>
       <p:ext uri="{BB962C8B-B14F-4D97-AF65-F5344CB8AC3E}">
-        <p14:creationId xmlns:p14="http://schemas.microsoft.com/office/powerpoint/2010/main" val="602663535"/>
+        <p14:creationId xmlns:p14="http://schemas.microsoft.com/office/powerpoint/2010/main" val="32774146"/>
       </p:ext>
     </p:extLst>
   </p:cSld>
@@ -20447,7 +20269,7 @@
           <p:cNvPr id="4" name="title">
             <a:extLst xmlns:a="http://schemas.openxmlformats.org/drawingml/2006/main">
               <a:ext uri="{FF2B5EF4-FFF2-40B4-BE49-F238E27FC236}">
-                <a16:creationId xmlns:a16="http://schemas.microsoft.com/office/drawing/2014/main" id="{AF5A3BB1-A386-4266-BF52-636E24DDA67D}"/>
+                <a16:creationId xmlns:a16="http://schemas.microsoft.com/office/drawing/2014/main" id="{4E6D2678-566E-4FB8-A2C6-43685DB3CD58}"/>
               </a:ext>
             </a:extLst>
           </p:cNvPr>
@@ -20603,7 +20425,7 @@
           <p:cNvPr id="2" name="body">
             <a:extLst xmlns:a="http://schemas.openxmlformats.org/drawingml/2006/main">
               <a:ext uri="{FF2B5EF4-FFF2-40B4-BE49-F238E27FC236}">
-                <a16:creationId xmlns:a16="http://schemas.microsoft.com/office/drawing/2014/main" id="{D29F1337-05E1-47D6-880C-A2BD850D7710}"/>
+                <a16:creationId xmlns:a16="http://schemas.microsoft.com/office/drawing/2014/main" id="{84CA9D82-08CA-4C09-9077-4C3D36C94491}"/>
               </a:ext>
             </a:extLst>
           </p:cNvPr>
@@ -20787,7 +20609,7 @@
           <p:cNvPr id="3" name="page">
             <a:extLst xmlns:a="http://schemas.openxmlformats.org/drawingml/2006/main">
               <a:ext uri="{FF2B5EF4-FFF2-40B4-BE49-F238E27FC236}">
-                <a16:creationId xmlns:a16="http://schemas.microsoft.com/office/drawing/2014/main" id="{54CE01AB-10F4-4071-A4BC-FE13509FE4C4}"/>
+                <a16:creationId xmlns:a16="http://schemas.microsoft.com/office/drawing/2014/main" id="{DA99B144-0E41-4B9E-9A7E-45354FEC2D0F}"/>
               </a:ext>
             </a:extLst>
           </p:cNvPr>
@@ -20941,7 +20763,7 @@
     </p:spTree>
     <p:extLst>
       <p:ext uri="{BB962C8B-B14F-4D97-AF65-F5344CB8AC3E}">
-        <p14:creationId xmlns:p14="http://schemas.microsoft.com/office/powerpoint/2010/main" val="715529322"/>
+        <p14:creationId xmlns:p14="http://schemas.microsoft.com/office/powerpoint/2010/main" val="220067388"/>
       </p:ext>
     </p:extLst>
   </p:cSld>
@@ -20972,7 +20794,7 @@
           <p:cNvPr id="4" name="title">
             <a:extLst xmlns:a="http://schemas.openxmlformats.org/drawingml/2006/main">
               <a:ext uri="{FF2B5EF4-FFF2-40B4-BE49-F238E27FC236}">
-                <a16:creationId xmlns:a16="http://schemas.microsoft.com/office/drawing/2014/main" id="{62E359A2-6737-4A39-80CC-4A9AAF223CFD}"/>
+                <a16:creationId xmlns:a16="http://schemas.microsoft.com/office/drawing/2014/main" id="{BFCFD1EF-BDB7-4E9B-B226-85C0B2014DC5}"/>
               </a:ext>
             </a:extLst>
           </p:cNvPr>
@@ -21128,7 +20950,7 @@
           <p:cNvPr id="2" name="body">
             <a:extLst xmlns:a="http://schemas.openxmlformats.org/drawingml/2006/main">
               <a:ext uri="{FF2B5EF4-FFF2-40B4-BE49-F238E27FC236}">
-                <a16:creationId xmlns:a16="http://schemas.microsoft.com/office/drawing/2014/main" id="{474F7E7C-229E-4C37-8848-E83421B11A86}"/>
+                <a16:creationId xmlns:a16="http://schemas.microsoft.com/office/drawing/2014/main" id="{4031063F-FC7C-4522-A1E6-E0F280DD3437}"/>
               </a:ext>
             </a:extLst>
           </p:cNvPr>
@@ -21312,7 +21134,7 @@
           <p:cNvPr id="3" name="page">
             <a:extLst xmlns:a="http://schemas.openxmlformats.org/drawingml/2006/main">
               <a:ext uri="{FF2B5EF4-FFF2-40B4-BE49-F238E27FC236}">
-                <a16:creationId xmlns:a16="http://schemas.microsoft.com/office/drawing/2014/main" id="{55252707-E029-4228-A7A6-5FAEC871BF29}"/>
+                <a16:creationId xmlns:a16="http://schemas.microsoft.com/office/drawing/2014/main" id="{C10CB3BF-ACA3-4C23-B76A-C251B8F2C6D0}"/>
               </a:ext>
             </a:extLst>
           </p:cNvPr>
@@ -21466,7 +21288,7 @@
     </p:spTree>
     <p:extLst>
       <p:ext uri="{BB962C8B-B14F-4D97-AF65-F5344CB8AC3E}">
-        <p14:creationId xmlns:p14="http://schemas.microsoft.com/office/powerpoint/2010/main" val="1619718866"/>
+        <p14:creationId xmlns:p14="http://schemas.microsoft.com/office/powerpoint/2010/main" val="634598738"/>
       </p:ext>
     </p:extLst>
   </p:cSld>
@@ -21497,7 +21319,7 @@
           <p:cNvPr id="4" name="title">
             <a:extLst xmlns:a="http://schemas.openxmlformats.org/drawingml/2006/main">
               <a:ext uri="{FF2B5EF4-FFF2-40B4-BE49-F238E27FC236}">
-                <a16:creationId xmlns:a16="http://schemas.microsoft.com/office/drawing/2014/main" id="{F0446F26-748E-4243-B9C2-E9311495E661}"/>
+                <a16:creationId xmlns:a16="http://schemas.microsoft.com/office/drawing/2014/main" id="{83C50D60-A4F7-4219-84F1-10DFB8086278}"/>
               </a:ext>
             </a:extLst>
           </p:cNvPr>
@@ -21653,7 +21475,7 @@
           <p:cNvPr id="2" name="body">
             <a:extLst xmlns:a="http://schemas.openxmlformats.org/drawingml/2006/main">
               <a:ext uri="{FF2B5EF4-FFF2-40B4-BE49-F238E27FC236}">
-                <a16:creationId xmlns:a16="http://schemas.microsoft.com/office/drawing/2014/main" id="{68A77548-D901-4D72-841C-9C4ABFB87BC0}"/>
+                <a16:creationId xmlns:a16="http://schemas.microsoft.com/office/drawing/2014/main" id="{658218F0-7CFA-40AA-8678-2486F578DFF8}"/>
               </a:ext>
             </a:extLst>
           </p:cNvPr>
@@ -21837,7 +21659,7 @@
           <p:cNvPr id="3" name="page">
             <a:extLst xmlns:a="http://schemas.openxmlformats.org/drawingml/2006/main">
               <a:ext uri="{FF2B5EF4-FFF2-40B4-BE49-F238E27FC236}">
-                <a16:creationId xmlns:a16="http://schemas.microsoft.com/office/drawing/2014/main" id="{776662E3-2051-440B-BCC4-2783DD16FEED}"/>
+                <a16:creationId xmlns:a16="http://schemas.microsoft.com/office/drawing/2014/main" id="{17547264-80A6-468F-8CB0-A2B541E48D6F}"/>
               </a:ext>
             </a:extLst>
           </p:cNvPr>
@@ -21991,7 +21813,7 @@
     </p:spTree>
     <p:extLst>
       <p:ext uri="{BB962C8B-B14F-4D97-AF65-F5344CB8AC3E}">
-        <p14:creationId xmlns:p14="http://schemas.microsoft.com/office/powerpoint/2010/main" val="968374758"/>
+        <p14:creationId xmlns:p14="http://schemas.microsoft.com/office/powerpoint/2010/main" val="921460539"/>
       </p:ext>
     </p:extLst>
   </p:cSld>
@@ -22022,7 +21844,7 @@
           <p:cNvPr id="4" name="title">
             <a:extLst xmlns:a="http://schemas.openxmlformats.org/drawingml/2006/main">
               <a:ext uri="{FF2B5EF4-FFF2-40B4-BE49-F238E27FC236}">
-                <a16:creationId xmlns:a16="http://schemas.microsoft.com/office/drawing/2014/main" id="{632963BE-CE5C-498F-A8FB-E1CE4086B9C4}"/>
+                <a16:creationId xmlns:a16="http://schemas.microsoft.com/office/drawing/2014/main" id="{6B188081-D0C0-41A1-9E19-5CA598657BE9}"/>
               </a:ext>
             </a:extLst>
           </p:cNvPr>
@@ -22178,7 +22000,7 @@
           <p:cNvPr id="2" name="body">
             <a:extLst xmlns:a="http://schemas.openxmlformats.org/drawingml/2006/main">
               <a:ext uri="{FF2B5EF4-FFF2-40B4-BE49-F238E27FC236}">
-                <a16:creationId xmlns:a16="http://schemas.microsoft.com/office/drawing/2014/main" id="{B7E319E5-41D7-48A5-B5B0-F1280FC6D702}"/>
+                <a16:creationId xmlns:a16="http://schemas.microsoft.com/office/drawing/2014/main" id="{F62EBD70-1D4E-4536-9712-9014A64A21B1}"/>
               </a:ext>
             </a:extLst>
           </p:cNvPr>
@@ -22362,7 +22184,7 @@
           <p:cNvPr id="3" name="page">
             <a:extLst xmlns:a="http://schemas.openxmlformats.org/drawingml/2006/main">
               <a:ext uri="{FF2B5EF4-FFF2-40B4-BE49-F238E27FC236}">
-                <a16:creationId xmlns:a16="http://schemas.microsoft.com/office/drawing/2014/main" id="{EDD8E6F6-B3CA-4BC6-B35F-397B92BD3B9B}"/>
+                <a16:creationId xmlns:a16="http://schemas.microsoft.com/office/drawing/2014/main" id="{D77ABF28-DEA3-430D-9E54-88D98BD7F36D}"/>
               </a:ext>
             </a:extLst>
           </p:cNvPr>
@@ -22516,7 +22338,7 @@
     </p:spTree>
     <p:extLst>
       <p:ext uri="{BB962C8B-B14F-4D97-AF65-F5344CB8AC3E}">
-        <p14:creationId xmlns:p14="http://schemas.microsoft.com/office/powerpoint/2010/main" val="1962097242"/>
+        <p14:creationId xmlns:p14="http://schemas.microsoft.com/office/powerpoint/2010/main" val="174301746"/>
       </p:ext>
     </p:extLst>
   </p:cSld>

</xml_diff>